<commit_message>
Company introduction, surprise vs. reaction read, no rating labels, four-size type scale, kicker without sector
- COMPANY_INTRO element under the quote (template, PPTX builder, fill.json, render_test)
- publication-day reaction as a mandatory input; divergence rule with confirmed drivers vs. interpretations
- no Buy/Hold/Sell or target prices; grep added to QA
- type scale 17 / 11 / 8.7 / 7 pt only, T_* constants in build_pptx.js, QA grep for the scale
- THEME removed from the kicker and the fill keys
- page-1 budgets recalibrated; PPTX text metric 0.475 -> 0.49 em/char
- calibration examples regenerated
</commit_message>
<xml_diff>
--- a/examples/layout_calibration.pptx
+++ b/examples/layout_calibration.pptx
@@ -1055,7 +1055,7 @@
       </p:grpSpPr>
       <p:pic>
         <p:nvPicPr>
-          <p:cNvPr id="2" name="Image 0" descr="/home/claude/syz_logo_new.png">    </p:cNvPr>
+          <p:cNvPr id="2" name="Image 0" descr="/home/claude/syz_logo_hq.png">    </p:cNvPr>
           <p:cNvPicPr>
             <a:picLocks noChangeAspect="1"/>
           </p:cNvPicPr>
@@ -1188,23 +1188,23 @@
         <p:spPr>
           <a:xfrm>
             <a:off x="539496" y="836676"/>
-            <a:ext cx="6483096" cy="164592"/>
-          </a:xfrm>
-          <a:prstGeom prst="rect">
-            <a:avLst/>
-          </a:prstGeom>
-          <a:noFill/>
-          <a:ln/>
-        </p:spPr>
-        <p:txBody>
-          <a:bodyPr wrap="square" lIns="0" tIns="0" rIns="0" bIns="0" rtlCol="0" anchor="t"/>
-          <a:lstStyle/>
-          <a:p>
-            <a:pPr indent="0" marL="0">
-              <a:buNone/>
-            </a:pPr>
-            <a:r>
-              <a:rPr lang="en-US" sz="800" b="1" spc="120" kern="0" dirty="0">
+            <a:ext cx="6483096" cy="155448"/>
+          </a:xfrm>
+          <a:prstGeom prst="rect">
+            <a:avLst/>
+          </a:prstGeom>
+          <a:noFill/>
+          <a:ln/>
+        </p:spPr>
+        <p:txBody>
+          <a:bodyPr wrap="square" lIns="0" tIns="0" rIns="0" bIns="0" rtlCol="0" anchor="t"/>
+          <a:lstStyle/>
+          <a:p>
+            <a:pPr indent="0" marL="0">
+              <a:buNone/>
+            </a:pPr>
+            <a:r>
+              <a:rPr lang="en-US" sz="700" b="1" spc="120" kern="0" dirty="0">
                 <a:solidFill>
                   <a:srgbClr val="FF6C0E"/>
                 </a:solidFill>
@@ -1212,9 +1212,9 @@
                 <a:ea typeface="Nunito" pitchFamily="34" charset="-122"/>
                 <a:cs typeface="Nunito" pitchFamily="34" charset="-120"/>
               </a:rPr>
-              <a:t>Earnings update · Semiconductors</a:t>
-            </a:r>
-            <a:endParaRPr lang="en-US" sz="800" dirty="0"/>
+              <a:t>Earnings update</a:t>
+            </a:r>
+            <a:endParaRPr lang="en-US" sz="700" dirty="0"/>
           </a:p>
         </p:txBody>
       </p:sp>
@@ -1226,7 +1226,7 @@
         </p:nvSpPr>
         <p:spPr>
           <a:xfrm>
-            <a:off x="539496" y="1028700"/>
+            <a:off x="539496" y="1019556"/>
             <a:ext cx="6483096" cy="526796"/>
           </a:xfrm>
           <a:prstGeom prst="rect">
@@ -1268,7 +1268,7 @@
         </p:nvSpPr>
         <p:spPr>
           <a:xfrm>
-            <a:off x="539496" y="1592072"/>
+            <a:off x="539496" y="1582928"/>
             <a:ext cx="6483096" cy="164592"/>
           </a:xfrm>
           <a:prstGeom prst="rect">
@@ -1285,7 +1285,7 @@
               <a:buNone/>
             </a:pPr>
             <a:r>
-              <a:rPr lang="en-US" sz="850" b="1" dirty="0">
+              <a:rPr lang="en-US" sz="870" b="1" dirty="0">
                 <a:solidFill>
                   <a:srgbClr val="6B7280"/>
                 </a:solidFill>
@@ -1295,7 +1295,7 @@
               </a:rPr>
               <a:t>14 October 2026 · Syz Research</a:t>
             </a:r>
-            <a:endParaRPr lang="en-US" sz="850" dirty="0"/>
+            <a:endParaRPr lang="en-US" sz="870" dirty="0"/>
           </a:p>
         </p:txBody>
       </p:sp>
@@ -1307,8 +1307,8 @@
         </p:nvSpPr>
         <p:spPr>
           <a:xfrm>
-            <a:off x="539496" y="1875536"/>
-            <a:ext cx="42977" cy="573786"/>
+            <a:off x="539496" y="1866392"/>
+            <a:ext cx="42977" cy="536067"/>
           </a:xfrm>
           <a:prstGeom prst="rect">
             <a:avLst/>
@@ -1332,8 +1332,8 @@
         </p:nvSpPr>
         <p:spPr>
           <a:xfrm>
-            <a:off x="722376" y="1893824"/>
-            <a:ext cx="6300216" cy="336042"/>
+            <a:off x="722376" y="1884680"/>
+            <a:ext cx="6300216" cy="298323"/>
           </a:xfrm>
           <a:prstGeom prst="rect">
             <a:avLst/>
@@ -1352,7 +1352,7 @@
               <a:buNone/>
             </a:pPr>
             <a:r>
-              <a:rPr lang="en-US" sz="980" b="1" dirty="0">
+              <a:rPr lang="en-US" sz="870" b="1" dirty="0">
                 <a:solidFill>
                   <a:srgbClr val="202945"/>
                 </a:solidFill>
@@ -1362,7 +1362,7 @@
               </a:rPr>
               <a:t>“Illustrative management quote of about twenty to thirty words that captures the tone of the call and the key message to investors.”</a:t>
             </a:r>
-            <a:endParaRPr lang="en-US" sz="980" dirty="0"/>
+            <a:endParaRPr lang="en-US" sz="870" dirty="0"/>
           </a:p>
         </p:txBody>
       </p:sp>
@@ -1374,7 +1374,7 @@
         </p:nvSpPr>
         <p:spPr>
           <a:xfrm>
-            <a:off x="722376" y="2266442"/>
+            <a:off x="722376" y="2219579"/>
             <a:ext cx="6300216" cy="155448"/>
           </a:xfrm>
           <a:prstGeom prst="rect">
@@ -1391,7 +1391,7 @@
               <a:buNone/>
             </a:pPr>
             <a:r>
-              <a:rPr lang="en-US" sz="760" b="1" dirty="0">
+              <a:rPr lang="en-US" sz="700" b="1" dirty="0">
                 <a:solidFill>
                   <a:srgbClr val="6B7280"/>
                 </a:solidFill>
@@ -1401,7 +1401,7 @@
               </a:rPr>
               <a:t>Illustrative Name, CEO, Q3 2026 earnings call, 14 October 2026</a:t>
             </a:r>
-            <a:endParaRPr lang="en-US" sz="760" dirty="0"/>
+            <a:endParaRPr lang="en-US" sz="700" dirty="0"/>
           </a:p>
         </p:txBody>
       </p:sp>
@@ -1413,98 +1413,20 @@
         </p:nvSpPr>
         <p:spPr>
           <a:xfrm>
-            <a:off x="539496" y="2568194"/>
-            <a:ext cx="6483096" cy="219456"/>
-          </a:xfrm>
-          <a:prstGeom prst="rect">
-            <a:avLst/>
-          </a:prstGeom>
-          <a:noFill/>
-          <a:ln/>
-        </p:spPr>
-        <p:txBody>
-          <a:bodyPr wrap="square" lIns="0" tIns="0" rIns="0" bIns="0" rtlCol="0" anchor="t"/>
-          <a:lstStyle/>
-          <a:p>
-            <a:pPr indent="0" marL="0">
-              <a:buNone/>
-            </a:pPr>
-            <a:r>
-              <a:rPr lang="en-US" sz="1100" b="1" dirty="0">
-                <a:solidFill>
-                  <a:srgbClr val="202945"/>
-                </a:solidFill>
-                <a:latin typeface="Nunito" pitchFamily="34" charset="0"/>
-                <a:ea typeface="Nunito" pitchFamily="34" charset="-122"/>
-                <a:cs typeface="Nunito" pitchFamily="34" charset="-120"/>
-              </a:rPr>
-              <a:t>Key takeaways</a:t>
-            </a:r>
-            <a:endParaRPr lang="en-US" sz="1100" dirty="0"/>
-          </a:p>
-        </p:txBody>
-      </p:sp>
-      <p:sp>
-        <p:nvSpPr>
-          <p:cNvPr id="13" name="Text 9"/>
-          <p:cNvSpPr txBox="1"/>
-          <p:nvPr/>
-        </p:nvSpPr>
-        <p:spPr>
-          <a:xfrm>
-            <a:off x="539496" y="2828798"/>
-            <a:ext cx="576072" cy="156896"/>
-          </a:xfrm>
-          <a:prstGeom prst="rect">
-            <a:avLst/>
-          </a:prstGeom>
-          <a:noFill/>
-          <a:ln/>
-        </p:spPr>
-        <p:txBody>
-          <a:bodyPr wrap="square" lIns="0" tIns="0" rIns="0" bIns="0" rtlCol="0" anchor="t"/>
-          <a:lstStyle/>
-          <a:p>
-            <a:pPr indent="0" marL="0">
-              <a:buNone/>
-            </a:pPr>
-            <a:r>
-              <a:rPr lang="en-US" sz="700" b="1" spc="80" kern="0" dirty="0">
-                <a:solidFill>
-                  <a:srgbClr val="3BAF90"/>
-                </a:solidFill>
-                <a:latin typeface="Nunito" pitchFamily="34" charset="0"/>
-                <a:ea typeface="Nunito" pitchFamily="34" charset="-122"/>
-                <a:cs typeface="Nunito" pitchFamily="34" charset="-120"/>
-              </a:rPr>
-              <a:t>Beat</a:t>
-            </a:r>
-            <a:endParaRPr lang="en-US" sz="700" dirty="0"/>
-          </a:p>
-        </p:txBody>
-      </p:sp>
-      <p:sp>
-        <p:nvSpPr>
-          <p:cNvPr id="14" name="Text 10"/>
-          <p:cNvSpPr txBox="1"/>
-          <p:nvPr/>
-        </p:nvSpPr>
-        <p:spPr>
-          <a:xfrm>
-            <a:off x="1133856" y="2805938"/>
-            <a:ext cx="5888736" cy="156896"/>
-          </a:xfrm>
-          <a:prstGeom prst="rect">
-            <a:avLst/>
-          </a:prstGeom>
-          <a:noFill/>
-          <a:ln/>
-        </p:spPr>
-        <p:txBody>
-          <a:bodyPr wrap="square" lIns="0" tIns="0" rIns="0" bIns="0" rtlCol="0" anchor="t"/>
-          <a:lstStyle/>
-          <a:p>
-            <a:pPr indent="0" marL="0">
+            <a:off x="539496" y="2521331"/>
+            <a:ext cx="6483096" cy="332080"/>
+          </a:xfrm>
+          <a:prstGeom prst="rect">
+            <a:avLst/>
+          </a:prstGeom>
+          <a:noFill/>
+          <a:ln/>
+        </p:spPr>
+        <p:txBody>
+          <a:bodyPr wrap="square" lIns="0" tIns="0" rIns="0" bIns="0" rtlCol="0" anchor="t"/>
+          <a:lstStyle/>
+          <a:p>
+            <a:pPr algn="just" indent="0" marL="0">
               <a:lnSpc>
                 <a:spcPct val="118333"/>
               </a:lnSpc>
@@ -1519,7 +1441,7 @@
                 <a:ea typeface="Nunito" pitchFamily="34" charset="-122"/>
                 <a:cs typeface="Nunito" pitchFamily="34" charset="-120"/>
               </a:rPr>
-              <a:t>Revenue EUR 9.2bn (+4% vs. consensus) and EPS EUR 7.85 (+6%), driven by EUV mix and services.</a:t>
+              <a:t>ASML is the sole supplier of extreme ultraviolet lithography systems, the machines that print the most advanced chips. Systems are three quarters of sales; 2025 revenue EUR 32bn. Listed in Amsterdam, market value around EUR 600bn.</a:t>
             </a:r>
             <a:endParaRPr lang="en-US" sz="870" dirty="0"/>
           </a:p>
@@ -1527,52 +1449,91 @@
       </p:sp>
       <p:sp>
         <p:nvSpPr>
+          <p:cNvPr id="13" name="Text 9"/>
+          <p:cNvSpPr txBox="1"/>
+          <p:nvPr/>
+        </p:nvSpPr>
+        <p:spPr>
+          <a:xfrm>
+            <a:off x="539496" y="2972283"/>
+            <a:ext cx="6483096" cy="219456"/>
+          </a:xfrm>
+          <a:prstGeom prst="rect">
+            <a:avLst/>
+          </a:prstGeom>
+          <a:noFill/>
+          <a:ln/>
+        </p:spPr>
+        <p:txBody>
+          <a:bodyPr wrap="square" lIns="0" tIns="0" rIns="0" bIns="0" rtlCol="0" anchor="t"/>
+          <a:lstStyle/>
+          <a:p>
+            <a:pPr indent="0" marL="0">
+              <a:buNone/>
+            </a:pPr>
+            <a:r>
+              <a:rPr lang="en-US" sz="1100" b="1" dirty="0">
+                <a:solidFill>
+                  <a:srgbClr val="202945"/>
+                </a:solidFill>
+                <a:latin typeface="Nunito" pitchFamily="34" charset="0"/>
+                <a:ea typeface="Nunito" pitchFamily="34" charset="-122"/>
+                <a:cs typeface="Nunito" pitchFamily="34" charset="-120"/>
+              </a:rPr>
+              <a:t>Key takeaways</a:t>
+            </a:r>
+            <a:endParaRPr lang="en-US" sz="1100" dirty="0"/>
+          </a:p>
+        </p:txBody>
+      </p:sp>
+      <p:sp>
+        <p:nvSpPr>
+          <p:cNvPr id="14" name="Text 10"/>
+          <p:cNvSpPr txBox="1"/>
+          <p:nvPr/>
+        </p:nvSpPr>
+        <p:spPr>
+          <a:xfrm>
+            <a:off x="539496" y="3232887"/>
+            <a:ext cx="576072" cy="156896"/>
+          </a:xfrm>
+          <a:prstGeom prst="rect">
+            <a:avLst/>
+          </a:prstGeom>
+          <a:noFill/>
+          <a:ln/>
+        </p:spPr>
+        <p:txBody>
+          <a:bodyPr wrap="square" lIns="0" tIns="0" rIns="0" bIns="0" rtlCol="0" anchor="t"/>
+          <a:lstStyle/>
+          <a:p>
+            <a:pPr indent="0" marL="0">
+              <a:buNone/>
+            </a:pPr>
+            <a:r>
+              <a:rPr lang="en-US" sz="700" b="1" spc="80" kern="0" dirty="0">
+                <a:solidFill>
+                  <a:srgbClr val="3BAF90"/>
+                </a:solidFill>
+                <a:latin typeface="Nunito" pitchFamily="34" charset="0"/>
+                <a:ea typeface="Nunito" pitchFamily="34" charset="-122"/>
+                <a:cs typeface="Nunito" pitchFamily="34" charset="-120"/>
+              </a:rPr>
+              <a:t>Beat</a:t>
+            </a:r>
+            <a:endParaRPr lang="en-US" sz="700" dirty="0"/>
+          </a:p>
+        </p:txBody>
+      </p:sp>
+      <p:sp>
+        <p:nvSpPr>
           <p:cNvPr id="15" name="Text 11"/>
           <p:cNvSpPr txBox="1"/>
           <p:nvPr/>
         </p:nvSpPr>
         <p:spPr>
           <a:xfrm>
-            <a:off x="539496" y="3031414"/>
-            <a:ext cx="576072" cy="156896"/>
-          </a:xfrm>
-          <a:prstGeom prst="rect">
-            <a:avLst/>
-          </a:prstGeom>
-          <a:noFill/>
-          <a:ln/>
-        </p:spPr>
-        <p:txBody>
-          <a:bodyPr wrap="square" lIns="0" tIns="0" rIns="0" bIns="0" rtlCol="0" anchor="t"/>
-          <a:lstStyle/>
-          <a:p>
-            <a:pPr indent="0" marL="0">
-              <a:buNone/>
-            </a:pPr>
-            <a:r>
-              <a:rPr lang="en-US" sz="700" b="1" spc="80" kern="0" dirty="0">
-                <a:solidFill>
-                  <a:srgbClr val="3BAF90"/>
-                </a:solidFill>
-                <a:latin typeface="Nunito" pitchFamily="34" charset="0"/>
-                <a:ea typeface="Nunito" pitchFamily="34" charset="-122"/>
-                <a:cs typeface="Nunito" pitchFamily="34" charset="-120"/>
-              </a:rPr>
-              <a:t>Raised</a:t>
-            </a:r>
-            <a:endParaRPr lang="en-US" sz="700" dirty="0"/>
-          </a:p>
-        </p:txBody>
-      </p:sp>
-      <p:sp>
-        <p:nvSpPr>
-          <p:cNvPr id="16" name="Text 12"/>
-          <p:cNvSpPr txBox="1"/>
-          <p:nvPr/>
-        </p:nvSpPr>
-        <p:spPr>
-          <a:xfrm>
-            <a:off x="1133856" y="3008554"/>
+            <a:off x="1133856" y="3210027"/>
             <a:ext cx="5888736" cy="156896"/>
           </a:xfrm>
           <a:prstGeom prst="rect">
@@ -1600,7 +1561,7 @@
                 <a:ea typeface="Nunito" pitchFamily="34" charset="-122"/>
                 <a:cs typeface="Nunito" pitchFamily="34" charset="-120"/>
               </a:rPr>
-              <a:t>FY26 revenue guide lifted to the top of the EUR 34 to 36bn range; gross margin 52 to 53%.</a:t>
+              <a:t>Revenue EUR 9.2bn (+4% vs. consensus) and EPS EUR 7.85 (+6%), driven by EUV mix and services.</a:t>
             </a:r>
             <a:endParaRPr lang="en-US" sz="870" dirty="0"/>
           </a:p>
@@ -1608,52 +1569,52 @@
       </p:sp>
       <p:sp>
         <p:nvSpPr>
+          <p:cNvPr id="16" name="Text 12"/>
+          <p:cNvSpPr txBox="1"/>
+          <p:nvPr/>
+        </p:nvSpPr>
+        <p:spPr>
+          <a:xfrm>
+            <a:off x="539496" y="3435502"/>
+            <a:ext cx="576072" cy="156896"/>
+          </a:xfrm>
+          <a:prstGeom prst="rect">
+            <a:avLst/>
+          </a:prstGeom>
+          <a:noFill/>
+          <a:ln/>
+        </p:spPr>
+        <p:txBody>
+          <a:bodyPr wrap="square" lIns="0" tIns="0" rIns="0" bIns="0" rtlCol="0" anchor="t"/>
+          <a:lstStyle/>
+          <a:p>
+            <a:pPr indent="0" marL="0">
+              <a:buNone/>
+            </a:pPr>
+            <a:r>
+              <a:rPr lang="en-US" sz="700" b="1" spc="80" kern="0" dirty="0">
+                <a:solidFill>
+                  <a:srgbClr val="FF6C0E"/>
+                </a:solidFill>
+                <a:latin typeface="Nunito" pitchFamily="34" charset="0"/>
+                <a:ea typeface="Nunito" pitchFamily="34" charset="-122"/>
+                <a:cs typeface="Nunito" pitchFamily="34" charset="-120"/>
+              </a:rPr>
+              <a:t>Reaction</a:t>
+            </a:r>
+            <a:endParaRPr lang="en-US" sz="700" dirty="0"/>
+          </a:p>
+        </p:txBody>
+      </p:sp>
+      <p:sp>
+        <p:nvSpPr>
           <p:cNvPr id="17" name="Text 13"/>
           <p:cNvSpPr txBox="1"/>
           <p:nvPr/>
         </p:nvSpPr>
         <p:spPr>
           <a:xfrm>
-            <a:off x="539496" y="3234030"/>
-            <a:ext cx="576072" cy="156896"/>
-          </a:xfrm>
-          <a:prstGeom prst="rect">
-            <a:avLst/>
-          </a:prstGeom>
-          <a:noFill/>
-          <a:ln/>
-        </p:spPr>
-        <p:txBody>
-          <a:bodyPr wrap="square" lIns="0" tIns="0" rIns="0" bIns="0" rtlCol="0" anchor="t"/>
-          <a:lstStyle/>
-          <a:p>
-            <a:pPr indent="0" marL="0">
-              <a:buNone/>
-            </a:pPr>
-            <a:r>
-              <a:rPr lang="en-US" sz="700" b="1" spc="80" kern="0" dirty="0">
-                <a:solidFill>
-                  <a:srgbClr val="FF6C0E"/>
-                </a:solidFill>
-                <a:latin typeface="Nunito" pitchFamily="34" charset="0"/>
-                <a:ea typeface="Nunito" pitchFamily="34" charset="-122"/>
-                <a:cs typeface="Nunito" pitchFamily="34" charset="-120"/>
-              </a:rPr>
-              <a:t>Watch</a:t>
-            </a:r>
-            <a:endParaRPr lang="en-US" sz="700" dirty="0"/>
-          </a:p>
-        </p:txBody>
-      </p:sp>
-      <p:sp>
-        <p:nvSpPr>
-          <p:cNvPr id="18" name="Text 14"/>
-          <p:cNvSpPr txBox="1"/>
-          <p:nvPr/>
-        </p:nvSpPr>
-        <p:spPr>
-          <a:xfrm>
-            <a:off x="1133856" y="3211170"/>
+            <a:off x="1133856" y="3412642"/>
             <a:ext cx="5888736" cy="156896"/>
           </a:xfrm>
           <a:prstGeom prst="rect">
@@ -1681,7 +1642,7 @@
                 <a:ea typeface="Nunito" pitchFamily="34" charset="-122"/>
                 <a:cs typeface="Nunito" pitchFamily="34" charset="-120"/>
               </a:rPr>
-              <a:t>China fell to 22% of system sales from 29%, and export-licence timing remains the main swing factor.</a:t>
+              <a:t>Shares fell 5.1% on the day (sector +0.3%): the Q4 guide, 2% below consensus, outweighed the beat.</a:t>
             </a:r>
             <a:endParaRPr lang="en-US" sz="870" dirty="0"/>
           </a:p>
@@ -1689,52 +1650,52 @@
       </p:sp>
       <p:sp>
         <p:nvSpPr>
+          <p:cNvPr id="18" name="Text 14"/>
+          <p:cNvSpPr txBox="1"/>
+          <p:nvPr/>
+        </p:nvSpPr>
+        <p:spPr>
+          <a:xfrm>
+            <a:off x="539496" y="3638118"/>
+            <a:ext cx="576072" cy="156896"/>
+          </a:xfrm>
+          <a:prstGeom prst="rect">
+            <a:avLst/>
+          </a:prstGeom>
+          <a:noFill/>
+          <a:ln/>
+        </p:spPr>
+        <p:txBody>
+          <a:bodyPr wrap="square" lIns="0" tIns="0" rIns="0" bIns="0" rtlCol="0" anchor="t"/>
+          <a:lstStyle/>
+          <a:p>
+            <a:pPr indent="0" marL="0">
+              <a:buNone/>
+            </a:pPr>
+            <a:r>
+              <a:rPr lang="en-US" sz="700" b="1" spc="80" kern="0" dirty="0">
+                <a:solidFill>
+                  <a:srgbClr val="FF6C0E"/>
+                </a:solidFill>
+                <a:latin typeface="Nunito" pitchFamily="34" charset="0"/>
+                <a:ea typeface="Nunito" pitchFamily="34" charset="-122"/>
+                <a:cs typeface="Nunito" pitchFamily="34" charset="-120"/>
+              </a:rPr>
+              <a:t>Watch</a:t>
+            </a:r>
+            <a:endParaRPr lang="en-US" sz="700" dirty="0"/>
+          </a:p>
+        </p:txBody>
+      </p:sp>
+      <p:sp>
+        <p:nvSpPr>
           <p:cNvPr id="19" name="Text 15"/>
           <p:cNvSpPr txBox="1"/>
           <p:nvPr/>
         </p:nvSpPr>
         <p:spPr>
           <a:xfrm>
-            <a:off x="539496" y="3436645"/>
-            <a:ext cx="576072" cy="156896"/>
-          </a:xfrm>
-          <a:prstGeom prst="rect">
-            <a:avLst/>
-          </a:prstGeom>
-          <a:noFill/>
-          <a:ln/>
-        </p:spPr>
-        <p:txBody>
-          <a:bodyPr wrap="square" lIns="0" tIns="0" rIns="0" bIns="0" rtlCol="0" anchor="t"/>
-          <a:lstStyle/>
-          <a:p>
-            <a:pPr indent="0" marL="0">
-              <a:buNone/>
-            </a:pPr>
-            <a:r>
-              <a:rPr lang="en-US" sz="700" b="1" spc="80" kern="0" dirty="0">
-                <a:solidFill>
-                  <a:srgbClr val="4B5F80"/>
-                </a:solidFill>
-                <a:latin typeface="Nunito" pitchFamily="34" charset="0"/>
-                <a:ea typeface="Nunito" pitchFamily="34" charset="-122"/>
-                <a:cs typeface="Nunito" pitchFamily="34" charset="-120"/>
-              </a:rPr>
-              <a:t>Valuation</a:t>
-            </a:r>
-            <a:endParaRPr lang="en-US" sz="700" dirty="0"/>
-          </a:p>
-        </p:txBody>
-      </p:sp>
-      <p:sp>
-        <p:nvSpPr>
-          <p:cNvPr id="20" name="Text 16"/>
-          <p:cNvSpPr txBox="1"/>
-          <p:nvPr/>
-        </p:nvSpPr>
-        <p:spPr>
-          <a:xfrm>
-            <a:off x="1133856" y="3413785"/>
+            <a:off x="1133856" y="3615258"/>
             <a:ext cx="5888736" cy="156896"/>
           </a:xfrm>
           <a:prstGeom prst="rect">
@@ -1762,6 +1723,87 @@
                 <a:ea typeface="Nunito" pitchFamily="34" charset="-122"/>
                 <a:cs typeface="Nunito" pitchFamily="34" charset="-120"/>
               </a:rPr>
+              <a:t>China fell to 22% of system sales from 29%, and export-licence timing remains the main swing factor.</a:t>
+            </a:r>
+            <a:endParaRPr lang="en-US" sz="870" dirty="0"/>
+          </a:p>
+        </p:txBody>
+      </p:sp>
+      <p:sp>
+        <p:nvSpPr>
+          <p:cNvPr id="20" name="Text 16"/>
+          <p:cNvSpPr txBox="1"/>
+          <p:nvPr/>
+        </p:nvSpPr>
+        <p:spPr>
+          <a:xfrm>
+            <a:off x="539496" y="3840734"/>
+            <a:ext cx="576072" cy="156896"/>
+          </a:xfrm>
+          <a:prstGeom prst="rect">
+            <a:avLst/>
+          </a:prstGeom>
+          <a:noFill/>
+          <a:ln/>
+        </p:spPr>
+        <p:txBody>
+          <a:bodyPr wrap="square" lIns="0" tIns="0" rIns="0" bIns="0" rtlCol="0" anchor="t"/>
+          <a:lstStyle/>
+          <a:p>
+            <a:pPr indent="0" marL="0">
+              <a:buNone/>
+            </a:pPr>
+            <a:r>
+              <a:rPr lang="en-US" sz="700" b="1" spc="80" kern="0" dirty="0">
+                <a:solidFill>
+                  <a:srgbClr val="4B5F80"/>
+                </a:solidFill>
+                <a:latin typeface="Nunito" pitchFamily="34" charset="0"/>
+                <a:ea typeface="Nunito" pitchFamily="34" charset="-122"/>
+                <a:cs typeface="Nunito" pitchFamily="34" charset="-120"/>
+              </a:rPr>
+              <a:t>Valuation</a:t>
+            </a:r>
+            <a:endParaRPr lang="en-US" sz="700" dirty="0"/>
+          </a:p>
+        </p:txBody>
+      </p:sp>
+      <p:sp>
+        <p:nvSpPr>
+          <p:cNvPr id="21" name="Text 17"/>
+          <p:cNvSpPr txBox="1"/>
+          <p:nvPr/>
+        </p:nvSpPr>
+        <p:spPr>
+          <a:xfrm>
+            <a:off x="1133856" y="3817874"/>
+            <a:ext cx="5888736" cy="156896"/>
+          </a:xfrm>
+          <a:prstGeom prst="rect">
+            <a:avLst/>
+          </a:prstGeom>
+          <a:noFill/>
+          <a:ln/>
+        </p:spPr>
+        <p:txBody>
+          <a:bodyPr wrap="square" lIns="0" tIns="0" rIns="0" bIns="0" rtlCol="0" anchor="t"/>
+          <a:lstStyle/>
+          <a:p>
+            <a:pPr indent="0" marL="0">
+              <a:lnSpc>
+                <a:spcPct val="118333"/>
+              </a:lnSpc>
+              <a:buNone/>
+            </a:pPr>
+            <a:r>
+              <a:rPr lang="en-US" sz="870" b="1" dirty="0">
+                <a:solidFill>
+                  <a:srgbClr val="202945"/>
+                </a:solidFill>
+                <a:latin typeface="Nunito" pitchFamily="34" charset="0"/>
+                <a:ea typeface="Nunito" pitchFamily="34" charset="-122"/>
+                <a:cs typeface="Nunito" pitchFamily="34" charset="-120"/>
+              </a:rPr>
               <a:t>30.6x forward earnings, 18% above the 2010 to 2026 average: the upcycle is priced, not the next leg.</a:t>
             </a:r>
             <a:endParaRPr lang="en-US" sz="870" dirty="0"/>
@@ -1770,14 +1812,14 @@
       </p:sp>
       <p:sp>
         <p:nvSpPr>
-          <p:cNvPr id="21" name="Shape 17"/>
+          <p:cNvPr id="22" name="Shape 18"/>
           <p:cNvSpPr/>
           <p:nvPr/>
         </p:nvSpPr>
         <p:spPr>
           <a:xfrm>
-            <a:off x="539496" y="3698697"/>
-            <a:ext cx="6483096" cy="676656"/>
+            <a:off x="539496" y="4102786"/>
+            <a:ext cx="6483096" cy="640080"/>
           </a:xfrm>
           <a:prstGeom prst="rect">
             <a:avLst/>
@@ -1795,30 +1837,30 @@
       </p:sp>
       <p:sp>
         <p:nvSpPr>
-          <p:cNvPr id="22" name="Text 18"/>
-          <p:cNvSpPr txBox="1"/>
-          <p:nvPr/>
-        </p:nvSpPr>
-        <p:spPr>
-          <a:xfrm>
-            <a:off x="649224" y="3780993"/>
-            <a:ext cx="1437894" cy="146304"/>
-          </a:xfrm>
-          <a:prstGeom prst="rect">
-            <a:avLst/>
-          </a:prstGeom>
-          <a:noFill/>
-          <a:ln/>
-        </p:spPr>
-        <p:txBody>
-          <a:bodyPr wrap="square" lIns="0" tIns="0" rIns="0" bIns="0" rtlCol="0" anchor="t"/>
-          <a:lstStyle/>
-          <a:p>
-            <a:pPr indent="0" marL="0">
-              <a:buNone/>
-            </a:pPr>
-            <a:r>
-              <a:rPr lang="en-US" sz="720" b="1" dirty="0">
+          <p:cNvPr id="23" name="Text 19"/>
+          <p:cNvSpPr txBox="1"/>
+          <p:nvPr/>
+        </p:nvSpPr>
+        <p:spPr>
+          <a:xfrm>
+            <a:off x="649224" y="4175938"/>
+            <a:ext cx="1437894" cy="137160"/>
+          </a:xfrm>
+          <a:prstGeom prst="rect">
+            <a:avLst/>
+          </a:prstGeom>
+          <a:noFill/>
+          <a:ln/>
+        </p:spPr>
+        <p:txBody>
+          <a:bodyPr wrap="square" lIns="0" tIns="0" rIns="0" bIns="0" rtlCol="0" anchor="t"/>
+          <a:lstStyle/>
+          <a:p>
+            <a:pPr indent="0" marL="0">
+              <a:buNone/>
+            </a:pPr>
+            <a:r>
+              <a:rPr lang="en-US" sz="700" b="1" dirty="0">
                 <a:solidFill>
                   <a:srgbClr val="6B7280"/>
                 </a:solidFill>
@@ -1828,36 +1870,36 @@
               </a:rPr>
               <a:t>Revenue</a:t>
             </a:r>
-            <a:endParaRPr lang="en-US" sz="720" dirty="0"/>
-          </a:p>
-        </p:txBody>
-      </p:sp>
-      <p:sp>
-        <p:nvSpPr>
-          <p:cNvPr id="23" name="Text 19"/>
-          <p:cNvSpPr txBox="1"/>
-          <p:nvPr/>
-        </p:nvSpPr>
-        <p:spPr>
-          <a:xfrm>
-            <a:off x="649224" y="3927297"/>
-            <a:ext cx="1437894" cy="237744"/>
-          </a:xfrm>
-          <a:prstGeom prst="rect">
-            <a:avLst/>
-          </a:prstGeom>
-          <a:noFill/>
-          <a:ln/>
-        </p:spPr>
-        <p:txBody>
-          <a:bodyPr wrap="square" lIns="0" tIns="0" rIns="0" bIns="0" rtlCol="0" anchor="t"/>
-          <a:lstStyle/>
-          <a:p>
-            <a:pPr indent="0" marL="0">
-              <a:buNone/>
-            </a:pPr>
-            <a:r>
-              <a:rPr lang="en-US" sz="1300" b="1" dirty="0">
+            <a:endParaRPr lang="en-US" sz="700" dirty="0"/>
+          </a:p>
+        </p:txBody>
+      </p:sp>
+      <p:sp>
+        <p:nvSpPr>
+          <p:cNvPr id="24" name="Text 20"/>
+          <p:cNvSpPr txBox="1"/>
+          <p:nvPr/>
+        </p:nvSpPr>
+        <p:spPr>
+          <a:xfrm>
+            <a:off x="649224" y="4313098"/>
+            <a:ext cx="1437894" cy="201168"/>
+          </a:xfrm>
+          <a:prstGeom prst="rect">
+            <a:avLst/>
+          </a:prstGeom>
+          <a:noFill/>
+          <a:ln/>
+        </p:spPr>
+        <p:txBody>
+          <a:bodyPr wrap="square" lIns="0" tIns="0" rIns="0" bIns="0" rtlCol="0" anchor="t"/>
+          <a:lstStyle/>
+          <a:p>
+            <a:pPr indent="0" marL="0">
+              <a:buNone/>
+            </a:pPr>
+            <a:r>
+              <a:rPr lang="en-US" sz="1100" b="1" dirty="0">
                 <a:solidFill>
                   <a:srgbClr val="202945"/>
                 </a:solidFill>
@@ -1867,36 +1909,36 @@
               </a:rPr>
               <a:t>EUR 9.2bn</a:t>
             </a:r>
-            <a:endParaRPr lang="en-US" sz="1300" dirty="0"/>
-          </a:p>
-        </p:txBody>
-      </p:sp>
-      <p:sp>
-        <p:nvSpPr>
-          <p:cNvPr id="24" name="Text 20"/>
-          <p:cNvSpPr txBox="1"/>
-          <p:nvPr/>
-        </p:nvSpPr>
-        <p:spPr>
-          <a:xfrm>
-            <a:off x="649224" y="4165041"/>
-            <a:ext cx="1437894" cy="146304"/>
-          </a:xfrm>
-          <a:prstGeom prst="rect">
-            <a:avLst/>
-          </a:prstGeom>
-          <a:noFill/>
-          <a:ln/>
-        </p:spPr>
-        <p:txBody>
-          <a:bodyPr wrap="square" lIns="0" tIns="0" rIns="0" bIns="0" rtlCol="0" anchor="t"/>
-          <a:lstStyle/>
-          <a:p>
-            <a:pPr indent="0" marL="0">
-              <a:buNone/>
-            </a:pPr>
-            <a:r>
-              <a:rPr lang="en-US" sz="720" b="1" dirty="0">
+            <a:endParaRPr lang="en-US" sz="1100" dirty="0"/>
+          </a:p>
+        </p:txBody>
+      </p:sp>
+      <p:sp>
+        <p:nvSpPr>
+          <p:cNvPr id="25" name="Text 21"/>
+          <p:cNvSpPr txBox="1"/>
+          <p:nvPr/>
+        </p:nvSpPr>
+        <p:spPr>
+          <a:xfrm>
+            <a:off x="649224" y="4523410"/>
+            <a:ext cx="1437894" cy="137160"/>
+          </a:xfrm>
+          <a:prstGeom prst="rect">
+            <a:avLst/>
+          </a:prstGeom>
+          <a:noFill/>
+          <a:ln/>
+        </p:spPr>
+        <p:txBody>
+          <a:bodyPr wrap="square" lIns="0" tIns="0" rIns="0" bIns="0" rtlCol="0" anchor="t"/>
+          <a:lstStyle/>
+          <a:p>
+            <a:pPr indent="0" marL="0">
+              <a:buNone/>
+            </a:pPr>
+            <a:r>
+              <a:rPr lang="en-US" sz="700" b="1" dirty="0">
                 <a:solidFill>
                   <a:srgbClr val="3BAF90"/>
                 </a:solidFill>
@@ -1906,20 +1948,20 @@
               </a:rPr>
               <a:t>+4.1% vs. consensus</a:t>
             </a:r>
-            <a:endParaRPr lang="en-US" sz="720" dirty="0"/>
-          </a:p>
-        </p:txBody>
-      </p:sp>
-      <p:sp>
-        <p:nvSpPr>
-          <p:cNvPr id="25" name="Shape 21"/>
+            <a:endParaRPr lang="en-US" sz="700" dirty="0"/>
+          </a:p>
+        </p:txBody>
+      </p:sp>
+      <p:sp>
+        <p:nvSpPr>
+          <p:cNvPr id="26" name="Shape 22"/>
           <p:cNvSpPr/>
           <p:nvPr/>
         </p:nvSpPr>
         <p:spPr>
           <a:xfrm>
-            <a:off x="2160270" y="3698697"/>
-            <a:ext cx="0" cy="676656"/>
+            <a:off x="2160270" y="4102786"/>
+            <a:ext cx="0" cy="640080"/>
           </a:xfrm>
           <a:prstGeom prst="line">
             <a:avLst/>
@@ -1935,30 +1977,30 @@
       </p:sp>
       <p:sp>
         <p:nvSpPr>
-          <p:cNvPr id="26" name="Text 22"/>
-          <p:cNvSpPr txBox="1"/>
-          <p:nvPr/>
-        </p:nvSpPr>
-        <p:spPr>
-          <a:xfrm>
-            <a:off x="2269998" y="3780993"/>
-            <a:ext cx="1437894" cy="146304"/>
-          </a:xfrm>
-          <a:prstGeom prst="rect">
-            <a:avLst/>
-          </a:prstGeom>
-          <a:noFill/>
-          <a:ln/>
-        </p:spPr>
-        <p:txBody>
-          <a:bodyPr wrap="square" lIns="0" tIns="0" rIns="0" bIns="0" rtlCol="0" anchor="t"/>
-          <a:lstStyle/>
-          <a:p>
-            <a:pPr indent="0" marL="0">
-              <a:buNone/>
-            </a:pPr>
-            <a:r>
-              <a:rPr lang="en-US" sz="720" b="1" dirty="0">
+          <p:cNvPr id="27" name="Text 23"/>
+          <p:cNvSpPr txBox="1"/>
+          <p:nvPr/>
+        </p:nvSpPr>
+        <p:spPr>
+          <a:xfrm>
+            <a:off x="2269998" y="4175938"/>
+            <a:ext cx="1437894" cy="137160"/>
+          </a:xfrm>
+          <a:prstGeom prst="rect">
+            <a:avLst/>
+          </a:prstGeom>
+          <a:noFill/>
+          <a:ln/>
+        </p:spPr>
+        <p:txBody>
+          <a:bodyPr wrap="square" lIns="0" tIns="0" rIns="0" bIns="0" rtlCol="0" anchor="t"/>
+          <a:lstStyle/>
+          <a:p>
+            <a:pPr indent="0" marL="0">
+              <a:buNone/>
+            </a:pPr>
+            <a:r>
+              <a:rPr lang="en-US" sz="700" b="1" dirty="0">
                 <a:solidFill>
                   <a:srgbClr val="6B7280"/>
                 </a:solidFill>
@@ -1968,36 +2010,36 @@
               </a:rPr>
               <a:t>EPS</a:t>
             </a:r>
-            <a:endParaRPr lang="en-US" sz="720" dirty="0"/>
-          </a:p>
-        </p:txBody>
-      </p:sp>
-      <p:sp>
-        <p:nvSpPr>
-          <p:cNvPr id="27" name="Text 23"/>
-          <p:cNvSpPr txBox="1"/>
-          <p:nvPr/>
-        </p:nvSpPr>
-        <p:spPr>
-          <a:xfrm>
-            <a:off x="2269998" y="3927297"/>
-            <a:ext cx="1437894" cy="237744"/>
-          </a:xfrm>
-          <a:prstGeom prst="rect">
-            <a:avLst/>
-          </a:prstGeom>
-          <a:noFill/>
-          <a:ln/>
-        </p:spPr>
-        <p:txBody>
-          <a:bodyPr wrap="square" lIns="0" tIns="0" rIns="0" bIns="0" rtlCol="0" anchor="t"/>
-          <a:lstStyle/>
-          <a:p>
-            <a:pPr indent="0" marL="0">
-              <a:buNone/>
-            </a:pPr>
-            <a:r>
-              <a:rPr lang="en-US" sz="1300" b="1" dirty="0">
+            <a:endParaRPr lang="en-US" sz="700" dirty="0"/>
+          </a:p>
+        </p:txBody>
+      </p:sp>
+      <p:sp>
+        <p:nvSpPr>
+          <p:cNvPr id="28" name="Text 24"/>
+          <p:cNvSpPr txBox="1"/>
+          <p:nvPr/>
+        </p:nvSpPr>
+        <p:spPr>
+          <a:xfrm>
+            <a:off x="2269998" y="4313098"/>
+            <a:ext cx="1437894" cy="201168"/>
+          </a:xfrm>
+          <a:prstGeom prst="rect">
+            <a:avLst/>
+          </a:prstGeom>
+          <a:noFill/>
+          <a:ln/>
+        </p:spPr>
+        <p:txBody>
+          <a:bodyPr wrap="square" lIns="0" tIns="0" rIns="0" bIns="0" rtlCol="0" anchor="t"/>
+          <a:lstStyle/>
+          <a:p>
+            <a:pPr indent="0" marL="0">
+              <a:buNone/>
+            </a:pPr>
+            <a:r>
+              <a:rPr lang="en-US" sz="1100" b="1" dirty="0">
                 <a:solidFill>
                   <a:srgbClr val="202945"/>
                 </a:solidFill>
@@ -2007,36 +2049,36 @@
               </a:rPr>
               <a:t>EUR 7.85</a:t>
             </a:r>
-            <a:endParaRPr lang="en-US" sz="1300" dirty="0"/>
-          </a:p>
-        </p:txBody>
-      </p:sp>
-      <p:sp>
-        <p:nvSpPr>
-          <p:cNvPr id="28" name="Text 24"/>
-          <p:cNvSpPr txBox="1"/>
-          <p:nvPr/>
-        </p:nvSpPr>
-        <p:spPr>
-          <a:xfrm>
-            <a:off x="2269998" y="4165041"/>
-            <a:ext cx="1437894" cy="146304"/>
-          </a:xfrm>
-          <a:prstGeom prst="rect">
-            <a:avLst/>
-          </a:prstGeom>
-          <a:noFill/>
-          <a:ln/>
-        </p:spPr>
-        <p:txBody>
-          <a:bodyPr wrap="square" lIns="0" tIns="0" rIns="0" bIns="0" rtlCol="0" anchor="t"/>
-          <a:lstStyle/>
-          <a:p>
-            <a:pPr indent="0" marL="0">
-              <a:buNone/>
-            </a:pPr>
-            <a:r>
-              <a:rPr lang="en-US" sz="720" b="1" dirty="0">
+            <a:endParaRPr lang="en-US" sz="1100" dirty="0"/>
+          </a:p>
+        </p:txBody>
+      </p:sp>
+      <p:sp>
+        <p:nvSpPr>
+          <p:cNvPr id="29" name="Text 25"/>
+          <p:cNvSpPr txBox="1"/>
+          <p:nvPr/>
+        </p:nvSpPr>
+        <p:spPr>
+          <a:xfrm>
+            <a:off x="2269998" y="4523410"/>
+            <a:ext cx="1437894" cy="137160"/>
+          </a:xfrm>
+          <a:prstGeom prst="rect">
+            <a:avLst/>
+          </a:prstGeom>
+          <a:noFill/>
+          <a:ln/>
+        </p:spPr>
+        <p:txBody>
+          <a:bodyPr wrap="square" lIns="0" tIns="0" rIns="0" bIns="0" rtlCol="0" anchor="t"/>
+          <a:lstStyle/>
+          <a:p>
+            <a:pPr indent="0" marL="0">
+              <a:buNone/>
+            </a:pPr>
+            <a:r>
+              <a:rPr lang="en-US" sz="700" b="1" dirty="0">
                 <a:solidFill>
                   <a:srgbClr val="3BAF90"/>
                 </a:solidFill>
@@ -2046,20 +2088,20 @@
               </a:rPr>
               <a:t>+5.6% vs. consensus</a:t>
             </a:r>
-            <a:endParaRPr lang="en-US" sz="720" dirty="0"/>
-          </a:p>
-        </p:txBody>
-      </p:sp>
-      <p:sp>
-        <p:nvSpPr>
-          <p:cNvPr id="29" name="Shape 25"/>
+            <a:endParaRPr lang="en-US" sz="700" dirty="0"/>
+          </a:p>
+        </p:txBody>
+      </p:sp>
+      <p:sp>
+        <p:nvSpPr>
+          <p:cNvPr id="30" name="Shape 26"/>
           <p:cNvSpPr/>
           <p:nvPr/>
         </p:nvSpPr>
         <p:spPr>
           <a:xfrm>
-            <a:off x="3781044" y="3698697"/>
-            <a:ext cx="0" cy="676656"/>
+            <a:off x="3781044" y="4102786"/>
+            <a:ext cx="0" cy="640080"/>
           </a:xfrm>
           <a:prstGeom prst="line">
             <a:avLst/>
@@ -2075,30 +2117,30 @@
       </p:sp>
       <p:sp>
         <p:nvSpPr>
-          <p:cNvPr id="30" name="Text 26"/>
-          <p:cNvSpPr txBox="1"/>
-          <p:nvPr/>
-        </p:nvSpPr>
-        <p:spPr>
-          <a:xfrm>
-            <a:off x="3890772" y="3780993"/>
-            <a:ext cx="1437894" cy="146304"/>
-          </a:xfrm>
-          <a:prstGeom prst="rect">
-            <a:avLst/>
-          </a:prstGeom>
-          <a:noFill/>
-          <a:ln/>
-        </p:spPr>
-        <p:txBody>
-          <a:bodyPr wrap="square" lIns="0" tIns="0" rIns="0" bIns="0" rtlCol="0" anchor="t"/>
-          <a:lstStyle/>
-          <a:p>
-            <a:pPr indent="0" marL="0">
-              <a:buNone/>
-            </a:pPr>
-            <a:r>
-              <a:rPr lang="en-US" sz="720" b="1" dirty="0">
+          <p:cNvPr id="31" name="Text 27"/>
+          <p:cNvSpPr txBox="1"/>
+          <p:nvPr/>
+        </p:nvSpPr>
+        <p:spPr>
+          <a:xfrm>
+            <a:off x="3890772" y="4175938"/>
+            <a:ext cx="1437894" cy="137160"/>
+          </a:xfrm>
+          <a:prstGeom prst="rect">
+            <a:avLst/>
+          </a:prstGeom>
+          <a:noFill/>
+          <a:ln/>
+        </p:spPr>
+        <p:txBody>
+          <a:bodyPr wrap="square" lIns="0" tIns="0" rIns="0" bIns="0" rtlCol="0" anchor="t"/>
+          <a:lstStyle/>
+          <a:p>
+            <a:pPr indent="0" marL="0">
+              <a:buNone/>
+            </a:pPr>
+            <a:r>
+              <a:rPr lang="en-US" sz="700" b="1" dirty="0">
                 <a:solidFill>
                   <a:srgbClr val="6B7280"/>
                 </a:solidFill>
@@ -2108,36 +2150,36 @@
               </a:rPr>
               <a:t>Gross margin</a:t>
             </a:r>
-            <a:endParaRPr lang="en-US" sz="720" dirty="0"/>
-          </a:p>
-        </p:txBody>
-      </p:sp>
-      <p:sp>
-        <p:nvSpPr>
-          <p:cNvPr id="31" name="Text 27"/>
-          <p:cNvSpPr txBox="1"/>
-          <p:nvPr/>
-        </p:nvSpPr>
-        <p:spPr>
-          <a:xfrm>
-            <a:off x="3890772" y="3927297"/>
-            <a:ext cx="1437894" cy="237744"/>
-          </a:xfrm>
-          <a:prstGeom prst="rect">
-            <a:avLst/>
-          </a:prstGeom>
-          <a:noFill/>
-          <a:ln/>
-        </p:spPr>
-        <p:txBody>
-          <a:bodyPr wrap="square" lIns="0" tIns="0" rIns="0" bIns="0" rtlCol="0" anchor="t"/>
-          <a:lstStyle/>
-          <a:p>
-            <a:pPr indent="0" marL="0">
-              <a:buNone/>
-            </a:pPr>
-            <a:r>
-              <a:rPr lang="en-US" sz="1300" b="1" dirty="0">
+            <a:endParaRPr lang="en-US" sz="700" dirty="0"/>
+          </a:p>
+        </p:txBody>
+      </p:sp>
+      <p:sp>
+        <p:nvSpPr>
+          <p:cNvPr id="32" name="Text 28"/>
+          <p:cNvSpPr txBox="1"/>
+          <p:nvPr/>
+        </p:nvSpPr>
+        <p:spPr>
+          <a:xfrm>
+            <a:off x="3890772" y="4313098"/>
+            <a:ext cx="1437894" cy="201168"/>
+          </a:xfrm>
+          <a:prstGeom prst="rect">
+            <a:avLst/>
+          </a:prstGeom>
+          <a:noFill/>
+          <a:ln/>
+        </p:spPr>
+        <p:txBody>
+          <a:bodyPr wrap="square" lIns="0" tIns="0" rIns="0" bIns="0" rtlCol="0" anchor="t"/>
+          <a:lstStyle/>
+          <a:p>
+            <a:pPr indent="0" marL="0">
+              <a:buNone/>
+            </a:pPr>
+            <a:r>
+              <a:rPr lang="en-US" sz="1100" b="1" dirty="0">
                 <a:solidFill>
                   <a:srgbClr val="202945"/>
                 </a:solidFill>
@@ -2147,36 +2189,36 @@
               </a:rPr>
               <a:t>53.4%</a:t>
             </a:r>
-            <a:endParaRPr lang="en-US" sz="1300" dirty="0"/>
-          </a:p>
-        </p:txBody>
-      </p:sp>
-      <p:sp>
-        <p:nvSpPr>
-          <p:cNvPr id="32" name="Text 28"/>
-          <p:cNvSpPr txBox="1"/>
-          <p:nvPr/>
-        </p:nvSpPr>
-        <p:spPr>
-          <a:xfrm>
-            <a:off x="3890772" y="4165041"/>
-            <a:ext cx="1437894" cy="146304"/>
-          </a:xfrm>
-          <a:prstGeom prst="rect">
-            <a:avLst/>
-          </a:prstGeom>
-          <a:noFill/>
-          <a:ln/>
-        </p:spPr>
-        <p:txBody>
-          <a:bodyPr wrap="square" lIns="0" tIns="0" rIns="0" bIns="0" rtlCol="0" anchor="t"/>
-          <a:lstStyle/>
-          <a:p>
-            <a:pPr indent="0" marL="0">
-              <a:buNone/>
-            </a:pPr>
-            <a:r>
-              <a:rPr lang="en-US" sz="720" b="1" dirty="0">
+            <a:endParaRPr lang="en-US" sz="1100" dirty="0"/>
+          </a:p>
+        </p:txBody>
+      </p:sp>
+      <p:sp>
+        <p:nvSpPr>
+          <p:cNvPr id="33" name="Text 29"/>
+          <p:cNvSpPr txBox="1"/>
+          <p:nvPr/>
+        </p:nvSpPr>
+        <p:spPr>
+          <a:xfrm>
+            <a:off x="3890772" y="4523410"/>
+            <a:ext cx="1437894" cy="137160"/>
+          </a:xfrm>
+          <a:prstGeom prst="rect">
+            <a:avLst/>
+          </a:prstGeom>
+          <a:noFill/>
+          <a:ln/>
+        </p:spPr>
+        <p:txBody>
+          <a:bodyPr wrap="square" lIns="0" tIns="0" rIns="0" bIns="0" rtlCol="0" anchor="t"/>
+          <a:lstStyle/>
+          <a:p>
+            <a:pPr indent="0" marL="0">
+              <a:buNone/>
+            </a:pPr>
+            <a:r>
+              <a:rPr lang="en-US" sz="700" b="1" dirty="0">
                 <a:solidFill>
                   <a:srgbClr val="3BAF90"/>
                 </a:solidFill>
@@ -2186,20 +2228,20 @@
               </a:rPr>
               <a:t>+80bp vs. consensus</a:t>
             </a:r>
-            <a:endParaRPr lang="en-US" sz="720" dirty="0"/>
-          </a:p>
-        </p:txBody>
-      </p:sp>
-      <p:sp>
-        <p:nvSpPr>
-          <p:cNvPr id="33" name="Shape 29"/>
+            <a:endParaRPr lang="en-US" sz="700" dirty="0"/>
+          </a:p>
+        </p:txBody>
+      </p:sp>
+      <p:sp>
+        <p:nvSpPr>
+          <p:cNvPr id="34" name="Shape 30"/>
           <p:cNvSpPr/>
           <p:nvPr/>
         </p:nvSpPr>
         <p:spPr>
           <a:xfrm>
-            <a:off x="5401818" y="3698697"/>
-            <a:ext cx="0" cy="676656"/>
+            <a:off x="5401818" y="4102786"/>
+            <a:ext cx="0" cy="640080"/>
           </a:xfrm>
           <a:prstGeom prst="line">
             <a:avLst/>
@@ -2215,30 +2257,30 @@
       </p:sp>
       <p:sp>
         <p:nvSpPr>
-          <p:cNvPr id="34" name="Text 30"/>
-          <p:cNvSpPr txBox="1"/>
-          <p:nvPr/>
-        </p:nvSpPr>
-        <p:spPr>
-          <a:xfrm>
-            <a:off x="5511546" y="3780993"/>
-            <a:ext cx="1437894" cy="146304"/>
-          </a:xfrm>
-          <a:prstGeom prst="rect">
-            <a:avLst/>
-          </a:prstGeom>
-          <a:noFill/>
-          <a:ln/>
-        </p:spPr>
-        <p:txBody>
-          <a:bodyPr wrap="square" lIns="0" tIns="0" rIns="0" bIns="0" rtlCol="0" anchor="t"/>
-          <a:lstStyle/>
-          <a:p>
-            <a:pPr indent="0" marL="0">
-              <a:buNone/>
-            </a:pPr>
-            <a:r>
-              <a:rPr lang="en-US" sz="720" b="1" dirty="0">
+          <p:cNvPr id="35" name="Text 31"/>
+          <p:cNvSpPr txBox="1"/>
+          <p:nvPr/>
+        </p:nvSpPr>
+        <p:spPr>
+          <a:xfrm>
+            <a:off x="5511546" y="4175938"/>
+            <a:ext cx="1437894" cy="137160"/>
+          </a:xfrm>
+          <a:prstGeom prst="rect">
+            <a:avLst/>
+          </a:prstGeom>
+          <a:noFill/>
+          <a:ln/>
+        </p:spPr>
+        <p:txBody>
+          <a:bodyPr wrap="square" lIns="0" tIns="0" rIns="0" bIns="0" rtlCol="0" anchor="t"/>
+          <a:lstStyle/>
+          <a:p>
+            <a:pPr indent="0" marL="0">
+              <a:buNone/>
+            </a:pPr>
+            <a:r>
+              <a:rPr lang="en-US" sz="700" b="1" dirty="0">
                 <a:solidFill>
                   <a:srgbClr val="6B7280"/>
                 </a:solidFill>
@@ -2248,36 +2290,36 @@
               </a:rPr>
               <a:t>Q4 revenue guide</a:t>
             </a:r>
-            <a:endParaRPr lang="en-US" sz="720" dirty="0"/>
-          </a:p>
-        </p:txBody>
-      </p:sp>
-      <p:sp>
-        <p:nvSpPr>
-          <p:cNvPr id="35" name="Text 31"/>
-          <p:cNvSpPr txBox="1"/>
-          <p:nvPr/>
-        </p:nvSpPr>
-        <p:spPr>
-          <a:xfrm>
-            <a:off x="5511546" y="3927297"/>
-            <a:ext cx="1437894" cy="237744"/>
-          </a:xfrm>
-          <a:prstGeom prst="rect">
-            <a:avLst/>
-          </a:prstGeom>
-          <a:noFill/>
-          <a:ln/>
-        </p:spPr>
-        <p:txBody>
-          <a:bodyPr wrap="square" lIns="0" tIns="0" rIns="0" bIns="0" rtlCol="0" anchor="t"/>
-          <a:lstStyle/>
-          <a:p>
-            <a:pPr indent="0" marL="0">
-              <a:buNone/>
-            </a:pPr>
-            <a:r>
-              <a:rPr lang="en-US" sz="1300" b="1" dirty="0">
+            <a:endParaRPr lang="en-US" sz="700" dirty="0"/>
+          </a:p>
+        </p:txBody>
+      </p:sp>
+      <p:sp>
+        <p:nvSpPr>
+          <p:cNvPr id="36" name="Text 32"/>
+          <p:cNvSpPr txBox="1"/>
+          <p:nvPr/>
+        </p:nvSpPr>
+        <p:spPr>
+          <a:xfrm>
+            <a:off x="5511546" y="4313098"/>
+            <a:ext cx="1437894" cy="201168"/>
+          </a:xfrm>
+          <a:prstGeom prst="rect">
+            <a:avLst/>
+          </a:prstGeom>
+          <a:noFill/>
+          <a:ln/>
+        </p:spPr>
+        <p:txBody>
+          <a:bodyPr wrap="square" lIns="0" tIns="0" rIns="0" bIns="0" rtlCol="0" anchor="t"/>
+          <a:lstStyle/>
+          <a:p>
+            <a:pPr indent="0" marL="0">
+              <a:buNone/>
+            </a:pPr>
+            <a:r>
+              <a:rPr lang="en-US" sz="1100" b="1" dirty="0">
                 <a:solidFill>
                   <a:srgbClr val="202945"/>
                 </a:solidFill>
@@ -2287,36 +2329,36 @@
               </a:rPr>
               <a:t>EUR 9.6bn</a:t>
             </a:r>
-            <a:endParaRPr lang="en-US" sz="1300" dirty="0"/>
-          </a:p>
-        </p:txBody>
-      </p:sp>
-      <p:sp>
-        <p:nvSpPr>
-          <p:cNvPr id="36" name="Text 32"/>
-          <p:cNvSpPr txBox="1"/>
-          <p:nvPr/>
-        </p:nvSpPr>
-        <p:spPr>
-          <a:xfrm>
-            <a:off x="5511546" y="4165041"/>
-            <a:ext cx="1437894" cy="146304"/>
-          </a:xfrm>
-          <a:prstGeom prst="rect">
-            <a:avLst/>
-          </a:prstGeom>
-          <a:noFill/>
-          <a:ln/>
-        </p:spPr>
-        <p:txBody>
-          <a:bodyPr wrap="square" lIns="0" tIns="0" rIns="0" bIns="0" rtlCol="0" anchor="t"/>
-          <a:lstStyle/>
-          <a:p>
-            <a:pPr indent="0" marL="0">
-              <a:buNone/>
-            </a:pPr>
-            <a:r>
-              <a:rPr lang="en-US" sz="720" b="1" dirty="0">
+            <a:endParaRPr lang="en-US" sz="1100" dirty="0"/>
+          </a:p>
+        </p:txBody>
+      </p:sp>
+      <p:sp>
+        <p:nvSpPr>
+          <p:cNvPr id="37" name="Text 33"/>
+          <p:cNvSpPr txBox="1"/>
+          <p:nvPr/>
+        </p:nvSpPr>
+        <p:spPr>
+          <a:xfrm>
+            <a:off x="5511546" y="4523410"/>
+            <a:ext cx="1437894" cy="137160"/>
+          </a:xfrm>
+          <a:prstGeom prst="rect">
+            <a:avLst/>
+          </a:prstGeom>
+          <a:noFill/>
+          <a:ln/>
+        </p:spPr>
+        <p:txBody>
+          <a:bodyPr wrap="square" lIns="0" tIns="0" rIns="0" bIns="0" rtlCol="0" anchor="t"/>
+          <a:lstStyle/>
+          <a:p>
+            <a:pPr indent="0" marL="0">
+              <a:buNone/>
+            </a:pPr>
+            <a:r>
+              <a:rPr lang="en-US" sz="700" b="1" dirty="0">
                 <a:solidFill>
                   <a:srgbClr val="FF6C0E"/>
                 </a:solidFill>
@@ -2326,19 +2368,19 @@
               </a:rPr>
               <a:t>-2.3% vs. consensus</a:t>
             </a:r>
-            <a:endParaRPr lang="en-US" sz="720" dirty="0"/>
-          </a:p>
-        </p:txBody>
-      </p:sp>
-      <p:sp>
-        <p:nvSpPr>
-          <p:cNvPr id="37" name="Text 33"/>
-          <p:cNvSpPr txBox="1"/>
-          <p:nvPr/>
-        </p:nvSpPr>
-        <p:spPr>
-          <a:xfrm>
-            <a:off x="539496" y="4494225"/>
+            <a:endParaRPr lang="en-US" sz="700" dirty="0"/>
+          </a:p>
+        </p:txBody>
+      </p:sp>
+      <p:sp>
+        <p:nvSpPr>
+          <p:cNvPr id="38" name="Text 34"/>
+          <p:cNvSpPr txBox="1"/>
+          <p:nvPr/>
+        </p:nvSpPr>
+        <p:spPr>
+          <a:xfrm>
+            <a:off x="539496" y="4861738"/>
             <a:ext cx="6483096" cy="219456"/>
           </a:xfrm>
           <a:prstGeom prst="rect">
@@ -2371,14 +2413,14 @@
       </p:sp>
       <p:sp>
         <p:nvSpPr>
-          <p:cNvPr id="38" name="Text 34"/>
-          <p:cNvSpPr txBox="1"/>
-          <p:nvPr/>
-        </p:nvSpPr>
-        <p:spPr>
-          <a:xfrm>
-            <a:off x="539496" y="4741113"/>
-            <a:ext cx="6483096" cy="645871"/>
+          <p:cNvPr id="39" name="Text 35"/>
+          <p:cNvSpPr txBox="1"/>
+          <p:nvPr/>
+        </p:nvSpPr>
+        <p:spPr>
+          <a:xfrm>
+            <a:off x="539496" y="5108626"/>
+            <a:ext cx="6483096" cy="488975"/>
           </a:xfrm>
           <a:prstGeom prst="rect">
             <a:avLst/>
@@ -2405,7 +2447,7 @@
                 <a:ea typeface="Nunito" pitchFamily="34" charset="-122"/>
                 <a:cs typeface="Nunito" pitchFamily="34" charset="-120"/>
               </a:rPr>
-              <a:t>Orders of EUR 7.1bn beat consensus by 12% and the EUV share rose to 58%, the highest since Q2 2024, while gross margin reached 53.4% against a guide of 51 to 53%. We read the mix shift as structural rather than cyclical, and the guidance for Q4 implies a run-rate above the FY27 consensus. The debate now moves from demand to capacity. Orders of EUR 7.1bn beat consensus by 12% and the EUV share rose to 58%, the highest since Q2 2024, while gross margin.</a:t>
+              <a:t>Orders of EUR 7.1bn beat consensus by 12% and the EUV share rose to 58%, the highest since Q2 2024, while gross margin reached 53.4% against a guide of 51 to 53%. We read the mix shift as structural rather than cyclical, and the guidance for Q4 implies a run-rate above the FY27 consensus. The debate now moves from demand.</a:t>
             </a:r>
             <a:endParaRPr lang="en-US" sz="870" dirty="0"/>
           </a:p>
@@ -2413,30 +2455,30 @@
       </p:sp>
       <p:sp>
         <p:nvSpPr>
-          <p:cNvPr id="39" name="Text 35"/>
-          <p:cNvSpPr txBox="1"/>
-          <p:nvPr/>
-        </p:nvSpPr>
-        <p:spPr>
-          <a:xfrm>
-            <a:off x="539496" y="5466537"/>
-            <a:ext cx="6483096" cy="182880"/>
-          </a:xfrm>
-          <a:prstGeom prst="rect">
-            <a:avLst/>
-          </a:prstGeom>
-          <a:noFill/>
-          <a:ln/>
-        </p:spPr>
-        <p:txBody>
-          <a:bodyPr wrap="square" lIns="0" tIns="0" rIns="0" bIns="0" rtlCol="0" anchor="t"/>
-          <a:lstStyle/>
-          <a:p>
-            <a:pPr indent="0" marL="0">
-              <a:buNone/>
-            </a:pPr>
-            <a:r>
-              <a:rPr lang="en-US" sz="950" b="1" dirty="0">
+          <p:cNvPr id="40" name="Text 36"/>
+          <p:cNvSpPr txBox="1"/>
+          <p:nvPr/>
+        </p:nvSpPr>
+        <p:spPr>
+          <a:xfrm>
+            <a:off x="539496" y="5677154"/>
+            <a:ext cx="6483096" cy="173736"/>
+          </a:xfrm>
+          <a:prstGeom prst="rect">
+            <a:avLst/>
+          </a:prstGeom>
+          <a:noFill/>
+          <a:ln/>
+        </p:spPr>
+        <p:txBody>
+          <a:bodyPr wrap="square" lIns="0" tIns="0" rIns="0" bIns="0" rtlCol="0" anchor="t"/>
+          <a:lstStyle/>
+          <a:p>
+            <a:pPr indent="0" marL="0">
+              <a:buNone/>
+            </a:pPr>
+            <a:r>
+              <a:rPr lang="en-US" sz="870" b="1" dirty="0">
                 <a:solidFill>
                   <a:srgbClr val="FF6C0E"/>
                 </a:solidFill>
@@ -2450,7 +2492,7 @@
               <a:buNone/>
             </a:pPr>
             <a:r>
-              <a:rPr lang="en-US" sz="950" b="1" dirty="0">
+              <a:rPr lang="en-US" sz="870" b="1" dirty="0">
                 <a:solidFill>
                   <a:srgbClr val="202945"/>
                 </a:solidFill>
@@ -2460,20 +2502,20 @@
               </a:rPr>
               <a:t> · ASML Q3 2026: results vs. consensus</a:t>
             </a:r>
-            <a:endParaRPr lang="en-US" sz="950" dirty="0"/>
-          </a:p>
-        </p:txBody>
-      </p:sp>
-      <p:sp>
-        <p:nvSpPr>
-          <p:cNvPr id="40" name="Text 36"/>
-          <p:cNvSpPr txBox="1"/>
-          <p:nvPr/>
-        </p:nvSpPr>
-        <p:spPr>
-          <a:xfrm>
-            <a:off x="539496" y="5649417"/>
-            <a:ext cx="6483096" cy="118872"/>
+            <a:endParaRPr lang="en-US" sz="870" dirty="0"/>
+          </a:p>
+        </p:txBody>
+      </p:sp>
+      <p:sp>
+        <p:nvSpPr>
+          <p:cNvPr id="41" name="Text 37"/>
+          <p:cNvSpPr txBox="1"/>
+          <p:nvPr/>
+        </p:nvSpPr>
+        <p:spPr>
+          <a:xfrm>
+            <a:off x="539496" y="5850890"/>
+            <a:ext cx="6483096" cy="115570"/>
           </a:xfrm>
           <a:prstGeom prst="rect">
             <a:avLst/>
@@ -2492,7 +2534,7 @@
               <a:buNone/>
             </a:pPr>
             <a:r>
-              <a:rPr lang="en-US" sz="720" b="1" dirty="0">
+              <a:rPr lang="en-US" sz="700" b="1" dirty="0">
                 <a:solidFill>
                   <a:srgbClr val="6B7280"/>
                 </a:solidFill>
@@ -2502,13 +2544,13 @@
               </a:rPr>
               <a:t>Surprise vs. Bloomberg consensus, % · guidance midpoint vs. consensus · illustrative numbers</a:t>
             </a:r>
-            <a:endParaRPr lang="en-US" sz="720" dirty="0"/>
+            <a:endParaRPr lang="en-US" sz="700" dirty="0"/>
           </a:p>
         </p:txBody>
       </p:sp>
       <p:pic>
         <p:nvPicPr>
-          <p:cNvPr id="41" name="Image 2" descr="/home/claude/c1_crop.png">    </p:cNvPr>
+          <p:cNvPr id="42" name="Image 2" descr="/home/claude/c1_crop.png">    </p:cNvPr>
           <p:cNvPicPr>
             <a:picLocks noChangeAspect="1"/>
           </p:cNvPicPr>
@@ -2522,8 +2564,8 @@
         </p:blipFill>
         <p:spPr>
           <a:xfrm>
-            <a:off x="1382298" y="5814009"/>
-            <a:ext cx="4797491" cy="1496817"/>
+            <a:off x="1641622" y="6012180"/>
+            <a:ext cx="4278843" cy="1334999"/>
           </a:xfrm>
           <a:prstGeom prst="rect">
             <a:avLst/>
@@ -2532,13 +2574,13 @@
       </p:pic>
       <p:sp>
         <p:nvSpPr>
-          <p:cNvPr id="42" name="Text 37"/>
-          <p:cNvSpPr txBox="1"/>
-          <p:nvPr/>
-        </p:nvSpPr>
-        <p:spPr>
-          <a:xfrm>
-            <a:off x="539496" y="7365690"/>
+          <p:cNvPr id="43" name="Text 38"/>
+          <p:cNvSpPr txBox="1"/>
+          <p:nvPr/>
+        </p:nvSpPr>
+        <p:spPr>
+          <a:xfrm>
+            <a:off x="539496" y="7402043"/>
             <a:ext cx="6483096" cy="488975"/>
           </a:xfrm>
           <a:prstGeom prst="rect">
@@ -2566,7 +2608,7 @@
                 <a:ea typeface="Nunito" pitchFamily="34" charset="-122"/>
                 <a:cs typeface="Nunito" pitchFamily="34" charset="-120"/>
               </a:rPr>
-              <a:t>Orders of EUR 7.1bn beat consensus by 12% and the EUV share rose to 58%, the highest since Q2 2024, while gross margin reached 53.4% against a guide of 51 to 53%. We read the mix shift as structural rather than cyclical, and the guidance for Q4 implies a run-rate above the FY27 consensus. The debate now moves from demand to capacity. Orders of EUR.</a:t>
+              <a:t>Orders of EUR 7.1bn beat consensus by 12% and the EUV share rose to 58%, the highest since Q2 2024, while gross margin reached 53.4% against a guide of 51 to 53%. We read the mix shift as structural rather than cyclical, and the guidance for Q4 implies a run-rate above the FY27 consensus. The.</a:t>
             </a:r>
             <a:endParaRPr lang="en-US" sz="870" dirty="0"/>
           </a:p>
@@ -2574,13 +2616,13 @@
       </p:sp>
       <p:sp>
         <p:nvSpPr>
-          <p:cNvPr id="43" name="Text 38"/>
-          <p:cNvSpPr txBox="1"/>
-          <p:nvPr/>
-        </p:nvSpPr>
-        <p:spPr>
-          <a:xfrm>
-            <a:off x="539496" y="7970795"/>
+          <p:cNvPr id="44" name="Text 39"/>
+          <p:cNvSpPr txBox="1"/>
+          <p:nvPr/>
+        </p:nvSpPr>
+        <p:spPr>
+          <a:xfrm>
+            <a:off x="539496" y="8007147"/>
             <a:ext cx="6483096" cy="219456"/>
           </a:xfrm>
           <a:prstGeom prst="rect">
@@ -2613,13 +2655,13 @@
       </p:sp>
       <p:sp>
         <p:nvSpPr>
-          <p:cNvPr id="44" name="Text 39"/>
-          <p:cNvSpPr txBox="1"/>
-          <p:nvPr/>
-        </p:nvSpPr>
-        <p:spPr>
-          <a:xfrm>
-            <a:off x="539496" y="8217683"/>
+          <p:cNvPr id="45" name="Text 40"/>
+          <p:cNvSpPr txBox="1"/>
+          <p:nvPr/>
+        </p:nvSpPr>
+        <p:spPr>
+          <a:xfrm>
+            <a:off x="539496" y="8254035"/>
             <a:ext cx="6483096" cy="645871"/>
           </a:xfrm>
           <a:prstGeom prst="rect">
@@ -2647,7 +2689,7 @@
                 <a:ea typeface="Nunito" pitchFamily="34" charset="-122"/>
                 <a:cs typeface="Nunito" pitchFamily="34" charset="-120"/>
               </a:rPr>
-              <a:t>Orders of EUR 7.1bn beat consensus by 12% and the EUV share rose to 58%, the highest since Q2 2024, while gross margin reached 53.4% against a guide of 51 to 53%. We read the mix shift as structural rather than cyclical, and the guidance for Q4 implies a run-rate above the FY27 consensus. The debate now moves from demand to capacity. Orders of EUR 7.1bn beat consensus by 12%.</a:t>
+              <a:t>Orders of EUR 7.1bn beat consensus by 12% and the EUV share rose to 58%, the highest since Q2 2024, while gross margin reached 53.4% against a guide of 51 to 53%. We read the mix shift as structural rather than cyclical, and the guidance for Q4 implies a run-rate above the FY27 consensus. The debate now moves from demand to capacity. Orders of EUR 7.1bn beat consensus by 12% and the EUV share rose to 58%, the highest since Q2 2024, while gross margin.</a:t>
             </a:r>
             <a:endParaRPr lang="en-US" sz="870" dirty="0"/>
           </a:p>
@@ -2655,14 +2697,14 @@
       </p:sp>
       <p:sp>
         <p:nvSpPr>
-          <p:cNvPr id="45" name="Shape 40"/>
+          <p:cNvPr id="46" name="Shape 41"/>
           <p:cNvSpPr/>
           <p:nvPr/>
         </p:nvSpPr>
         <p:spPr>
           <a:xfrm>
-            <a:off x="3781044" y="8979683"/>
-            <a:ext cx="0" cy="985647"/>
+            <a:off x="3781044" y="9016035"/>
+            <a:ext cx="0" cy="828751"/>
           </a:xfrm>
           <a:prstGeom prst="line">
             <a:avLst/>
@@ -2678,13 +2720,13 @@
       </p:sp>
       <p:sp>
         <p:nvSpPr>
-          <p:cNvPr id="46" name="Text 41"/>
-          <p:cNvSpPr txBox="1"/>
-          <p:nvPr/>
-        </p:nvSpPr>
-        <p:spPr>
-          <a:xfrm>
-            <a:off x="539496" y="8979683"/>
+          <p:cNvPr id="47" name="Text 42"/>
+          <p:cNvSpPr txBox="1"/>
+          <p:nvPr/>
+        </p:nvSpPr>
+        <p:spPr>
+          <a:xfrm>
+            <a:off x="539496" y="9016035"/>
             <a:ext cx="3058668" cy="155448"/>
           </a:xfrm>
           <a:prstGeom prst="rect">
@@ -2701,7 +2743,7 @@
               <a:buNone/>
             </a:pPr>
             <a:r>
-              <a:rPr lang="en-US" sz="780" b="1" spc="100" kern="0" dirty="0">
+              <a:rPr lang="en-US" sz="700" b="1" spc="100" kern="0" dirty="0">
                 <a:solidFill>
                   <a:srgbClr val="FF6C0E"/>
                 </a:solidFill>
@@ -2711,20 +2753,20 @@
               </a:rPr>
               <a:t>What would strengthen our view</a:t>
             </a:r>
-            <a:endParaRPr lang="en-US" sz="780" dirty="0"/>
-          </a:p>
-        </p:txBody>
-      </p:sp>
-      <p:sp>
-        <p:nvSpPr>
-          <p:cNvPr id="47" name="Text 42"/>
-          <p:cNvSpPr txBox="1"/>
-          <p:nvPr/>
-        </p:nvSpPr>
-        <p:spPr>
-          <a:xfrm>
-            <a:off x="539496" y="9171707"/>
-            <a:ext cx="3058668" cy="784479"/>
+            <a:endParaRPr lang="en-US" sz="700" dirty="0"/>
+          </a:p>
+        </p:txBody>
+      </p:sp>
+      <p:sp>
+        <p:nvSpPr>
+          <p:cNvPr id="48" name="Text 43"/>
+          <p:cNvSpPr txBox="1"/>
+          <p:nvPr/>
+        </p:nvSpPr>
+        <p:spPr>
+          <a:xfrm>
+            <a:off x="539496" y="9208059"/>
+            <a:ext cx="3058668" cy="627583"/>
           </a:xfrm>
           <a:prstGeom prst="rect">
             <a:avLst/>
@@ -2751,7 +2793,7 @@
                 <a:ea typeface="Nunito" pitchFamily="34" charset="-122"/>
                 <a:cs typeface="Nunito" pitchFamily="34" charset="-120"/>
               </a:rPr>
-              <a:t>Orders of EUR 7.1bn beat consensus by 12% and the EUV share rose to 58%, the highest since Q2 2024, while gross margin reached 53.4% against a guide of 51 to 53%. We read the mix shift as structural rather than cyclical, and the guidance for Q4 implies a run-rate.</a:t>
+              <a:t>Orders of EUR 7.1bn beat consensus by 12% and the EUV share rose to 58%, the highest since Q2 2024, while gross margin reached 53.4% against a guide of 51 to 53%. We read the mix.</a:t>
             </a:r>
             <a:endParaRPr lang="en-US" sz="870" dirty="0"/>
           </a:p>
@@ -2759,13 +2801,13 @@
       </p:sp>
       <p:sp>
         <p:nvSpPr>
-          <p:cNvPr id="48" name="Text 43"/>
-          <p:cNvSpPr txBox="1"/>
-          <p:nvPr/>
-        </p:nvSpPr>
-        <p:spPr>
-          <a:xfrm>
-            <a:off x="3963924" y="8979683"/>
+          <p:cNvPr id="49" name="Text 44"/>
+          <p:cNvSpPr txBox="1"/>
+          <p:nvPr/>
+        </p:nvSpPr>
+        <p:spPr>
+          <a:xfrm>
+            <a:off x="3963924" y="9016035"/>
             <a:ext cx="3058668" cy="155448"/>
           </a:xfrm>
           <a:prstGeom prst="rect">
@@ -2782,7 +2824,7 @@
               <a:buNone/>
             </a:pPr>
             <a:r>
-              <a:rPr lang="en-US" sz="780" b="1" spc="100" kern="0" dirty="0">
+              <a:rPr lang="en-US" sz="700" b="1" spc="100" kern="0" dirty="0">
                 <a:solidFill>
                   <a:srgbClr val="FF6C0E"/>
                 </a:solidFill>
@@ -2792,20 +2834,20 @@
               </a:rPr>
               <a:t>What would change our view</a:t>
             </a:r>
-            <a:endParaRPr lang="en-US" sz="780" dirty="0"/>
-          </a:p>
-        </p:txBody>
-      </p:sp>
-      <p:sp>
-        <p:nvSpPr>
-          <p:cNvPr id="49" name="Text 44"/>
-          <p:cNvSpPr txBox="1"/>
-          <p:nvPr/>
-        </p:nvSpPr>
-        <p:spPr>
-          <a:xfrm>
-            <a:off x="3963924" y="9171707"/>
-            <a:ext cx="3058668" cy="784479"/>
+            <a:endParaRPr lang="en-US" sz="700" dirty="0"/>
+          </a:p>
+        </p:txBody>
+      </p:sp>
+      <p:sp>
+        <p:nvSpPr>
+          <p:cNvPr id="50" name="Text 45"/>
+          <p:cNvSpPr txBox="1"/>
+          <p:nvPr/>
+        </p:nvSpPr>
+        <p:spPr>
+          <a:xfrm>
+            <a:off x="3963924" y="9208059"/>
+            <a:ext cx="3058668" cy="627583"/>
           </a:xfrm>
           <a:prstGeom prst="rect">
             <a:avLst/>
@@ -2832,7 +2874,7 @@
                 <a:ea typeface="Nunito" pitchFamily="34" charset="-122"/>
                 <a:cs typeface="Nunito" pitchFamily="34" charset="-120"/>
               </a:rPr>
-              <a:t>Orders of EUR 7.1bn beat consensus by 12% and the EUV share rose to 58%, the highest since Q2 2024, while gross margin reached 53.4% against a guide of 51 to 53%. We read the mix shift as structural rather than cyclical, and the guidance for Q4 implies a run-rate.</a:t>
+              <a:t>Orders of EUR 7.1bn beat consensus by 12% and the EUV share rose to 58%, the highest since Q2 2024, while gross margin reached 53.4% against a guide of 51 to 53%. We read the mix.</a:t>
             </a:r>
             <a:endParaRPr lang="en-US" sz="870" dirty="0"/>
           </a:p>
@@ -2872,7 +2914,7 @@
       </p:grpSpPr>
       <p:pic>
         <p:nvPicPr>
-          <p:cNvPr id="2" name="Image 0" descr="/home/claude/syz_logo_new.png">    </p:cNvPr>
+          <p:cNvPr id="2" name="Image 0" descr="/home/claude/syz_logo_hq.png">    </p:cNvPr>
           <p:cNvPicPr>
             <a:picLocks noChangeAspect="1"/>
           </p:cNvPicPr>
@@ -3005,6 +3047,45 @@
         <p:spPr>
           <a:xfrm>
             <a:off x="539496" y="836676"/>
+            <a:ext cx="6483096" cy="329184"/>
+          </a:xfrm>
+          <a:prstGeom prst="rect">
+            <a:avLst/>
+          </a:prstGeom>
+          <a:noFill/>
+          <a:ln/>
+        </p:spPr>
+        <p:txBody>
+          <a:bodyPr wrap="square" lIns="0" tIns="0" rIns="0" bIns="0" rtlCol="0" anchor="t"/>
+          <a:lstStyle/>
+          <a:p>
+            <a:pPr indent="0" marL="0">
+              <a:buNone/>
+            </a:pPr>
+            <a:r>
+              <a:rPr lang="en-US" sz="1700" b="1" dirty="0">
+                <a:solidFill>
+                  <a:srgbClr val="202945"/>
+                </a:solidFill>
+                <a:latin typeface="Nunito" pitchFamily="34" charset="0"/>
+                <a:ea typeface="Nunito" pitchFamily="34" charset="-122"/>
+                <a:cs typeface="Nunito" pitchFamily="34" charset="-120"/>
+              </a:rPr>
+              <a:t>Beyond the key takeaways</a:t>
+            </a:r>
+            <a:endParaRPr lang="en-US" sz="1700" dirty="0"/>
+          </a:p>
+        </p:txBody>
+      </p:sp>
+      <p:sp>
+        <p:nvSpPr>
+          <p:cNvPr id="7" name="Text 3"/>
+          <p:cNvSpPr txBox="1"/>
+          <p:nvPr/>
+        </p:nvSpPr>
+        <p:spPr>
+          <a:xfrm>
+            <a:off x="539496" y="1239012"/>
             <a:ext cx="6483096" cy="219456"/>
           </a:xfrm>
           <a:prstGeom prst="rect">
@@ -3037,13 +3118,13 @@
       </p:sp>
       <p:sp>
         <p:nvSpPr>
-          <p:cNvPr id="7" name="Text 3"/>
-          <p:cNvSpPr txBox="1"/>
-          <p:nvPr/>
-        </p:nvSpPr>
-        <p:spPr>
-          <a:xfrm>
-            <a:off x="539496" y="1083564"/>
+          <p:cNvPr id="8" name="Text 4"/>
+          <p:cNvSpPr txBox="1"/>
+          <p:nvPr/>
+        </p:nvSpPr>
+        <p:spPr>
+          <a:xfrm>
+            <a:off x="539496" y="1485900"/>
             <a:ext cx="6483096" cy="802767"/>
           </a:xfrm>
           <a:prstGeom prst="rect">
@@ -3079,13 +3160,13 @@
       </p:sp>
       <p:sp>
         <p:nvSpPr>
-          <p:cNvPr id="8" name="Text 4"/>
-          <p:cNvSpPr txBox="1"/>
-          <p:nvPr/>
-        </p:nvSpPr>
-        <p:spPr>
-          <a:xfrm>
-            <a:off x="539496" y="1965884"/>
+          <p:cNvPr id="9" name="Text 5"/>
+          <p:cNvSpPr txBox="1"/>
+          <p:nvPr/>
+        </p:nvSpPr>
+        <p:spPr>
+          <a:xfrm>
+            <a:off x="539496" y="2368220"/>
             <a:ext cx="6483096" cy="802767"/>
           </a:xfrm>
           <a:prstGeom prst="rect">
@@ -3121,13 +3202,13 @@
       </p:sp>
       <p:sp>
         <p:nvSpPr>
-          <p:cNvPr id="9" name="Text 5"/>
-          <p:cNvSpPr txBox="1"/>
-          <p:nvPr/>
-        </p:nvSpPr>
-        <p:spPr>
-          <a:xfrm>
-            <a:off x="539496" y="2884780"/>
+          <p:cNvPr id="10" name="Text 6"/>
+          <p:cNvSpPr txBox="1"/>
+          <p:nvPr/>
+        </p:nvSpPr>
+        <p:spPr>
+          <a:xfrm>
+            <a:off x="539496" y="3287116"/>
             <a:ext cx="6483096" cy="219456"/>
           </a:xfrm>
           <a:prstGeom prst="rect">
@@ -3160,13 +3241,13 @@
       </p:sp>
       <p:sp>
         <p:nvSpPr>
-          <p:cNvPr id="10" name="Text 6"/>
-          <p:cNvSpPr txBox="1"/>
-          <p:nvPr/>
-        </p:nvSpPr>
-        <p:spPr>
-          <a:xfrm>
-            <a:off x="539496" y="3131668"/>
+          <p:cNvPr id="11" name="Text 7"/>
+          <p:cNvSpPr txBox="1"/>
+          <p:nvPr/>
+        </p:nvSpPr>
+        <p:spPr>
+          <a:xfrm>
+            <a:off x="539496" y="3534004"/>
             <a:ext cx="6483096" cy="802767"/>
           </a:xfrm>
           <a:prstGeom prst="rect">
@@ -3202,13 +3283,13 @@
       </p:sp>
       <p:sp>
         <p:nvSpPr>
-          <p:cNvPr id="11" name="Text 7"/>
-          <p:cNvSpPr txBox="1"/>
-          <p:nvPr/>
-        </p:nvSpPr>
-        <p:spPr>
-          <a:xfrm>
-            <a:off x="539496" y="4050563"/>
+          <p:cNvPr id="12" name="Text 8"/>
+          <p:cNvSpPr txBox="1"/>
+          <p:nvPr/>
+        </p:nvSpPr>
+        <p:spPr>
+          <a:xfrm>
+            <a:off x="539496" y="4452899"/>
             <a:ext cx="6483096" cy="219456"/>
           </a:xfrm>
           <a:prstGeom prst="rect">
@@ -3241,30 +3322,30 @@
       </p:sp>
       <p:sp>
         <p:nvSpPr>
-          <p:cNvPr id="12" name="Text 8"/>
-          <p:cNvSpPr txBox="1"/>
-          <p:nvPr/>
-        </p:nvSpPr>
-        <p:spPr>
-          <a:xfrm>
-            <a:off x="539496" y="4297451"/>
-            <a:ext cx="6483096" cy="182880"/>
-          </a:xfrm>
-          <a:prstGeom prst="rect">
-            <a:avLst/>
-          </a:prstGeom>
-          <a:noFill/>
-          <a:ln/>
-        </p:spPr>
-        <p:txBody>
-          <a:bodyPr wrap="square" lIns="0" tIns="0" rIns="0" bIns="0" rtlCol="0" anchor="t"/>
-          <a:lstStyle/>
-          <a:p>
-            <a:pPr indent="0" marL="0">
-              <a:buNone/>
-            </a:pPr>
-            <a:r>
-              <a:rPr lang="en-US" sz="950" b="1" dirty="0">
+          <p:cNvPr id="13" name="Text 9"/>
+          <p:cNvSpPr txBox="1"/>
+          <p:nvPr/>
+        </p:nvSpPr>
+        <p:spPr>
+          <a:xfrm>
+            <a:off x="539496" y="4699787"/>
+            <a:ext cx="6483096" cy="173736"/>
+          </a:xfrm>
+          <a:prstGeom prst="rect">
+            <a:avLst/>
+          </a:prstGeom>
+          <a:noFill/>
+          <a:ln/>
+        </p:spPr>
+        <p:txBody>
+          <a:bodyPr wrap="square" lIns="0" tIns="0" rIns="0" bIns="0" rtlCol="0" anchor="t"/>
+          <a:lstStyle/>
+          <a:p>
+            <a:pPr indent="0" marL="0">
+              <a:buNone/>
+            </a:pPr>
+            <a:r>
+              <a:rPr lang="en-US" sz="870" b="1" dirty="0">
                 <a:solidFill>
                   <a:srgbClr val="FF6C0E"/>
                 </a:solidFill>
@@ -3278,7 +3359,7 @@
               <a:buNone/>
             </a:pPr>
             <a:r>
-              <a:rPr lang="en-US" sz="950" b="1" dirty="0">
+              <a:rPr lang="en-US" sz="870" b="1" dirty="0">
                 <a:solidFill>
                   <a:srgbClr val="202945"/>
                 </a:solidFill>
@@ -3288,20 +3369,20 @@
               </a:rPr>
               <a:t> · ASML: share price vs. consensus earnings and valuation</a:t>
             </a:r>
-            <a:endParaRPr lang="en-US" sz="950" dirty="0"/>
-          </a:p>
-        </p:txBody>
-      </p:sp>
-      <p:sp>
-        <p:nvSpPr>
-          <p:cNvPr id="13" name="Text 9"/>
-          <p:cNvSpPr txBox="1"/>
-          <p:nvPr/>
-        </p:nvSpPr>
-        <p:spPr>
-          <a:xfrm>
-            <a:off x="539496" y="4480331"/>
-            <a:ext cx="6483096" cy="237744"/>
+            <a:endParaRPr lang="en-US" sz="870" dirty="0"/>
+          </a:p>
+        </p:txBody>
+      </p:sp>
+      <p:sp>
+        <p:nvSpPr>
+          <p:cNvPr id="14" name="Text 10"/>
+          <p:cNvSpPr txBox="1"/>
+          <p:nvPr/>
+        </p:nvSpPr>
+        <p:spPr>
+          <a:xfrm>
+            <a:off x="539496" y="4873523"/>
+            <a:ext cx="6483096" cy="231140"/>
           </a:xfrm>
           <a:prstGeom prst="rect">
             <a:avLst/>
@@ -3320,7 +3401,7 @@
               <a:buNone/>
             </a:pPr>
             <a:r>
-              <a:rPr lang="en-US" sz="720" b="1" dirty="0">
+              <a:rPr lang="en-US" sz="700" b="1" dirty="0">
                 <a:solidFill>
                   <a:srgbClr val="6B7280"/>
                 </a:solidFill>
@@ -3330,13 +3411,13 @@
               </a:rPr>
               <a:t>ASML NA Equity, weekly · BEst 12m-forward consensus · 40-week simple MA · log scale · P/E shaded above (orange) / below (blue) its 2010 to 2026 average</a:t>
             </a:r>
-            <a:endParaRPr lang="en-US" sz="720" dirty="0"/>
+            <a:endParaRPr lang="en-US" sz="700" dirty="0"/>
           </a:p>
         </p:txBody>
       </p:sp>
       <p:pic>
         <p:nvPicPr>
-          <p:cNvPr id="14" name="Image 2" descr="/home/claude/c2_crop.png">    </p:cNvPr>
+          <p:cNvPr id="15" name="Image 2" descr="/home/claude/c2_crop.png">    </p:cNvPr>
           <p:cNvPicPr>
             <a:picLocks noChangeAspect="1"/>
           </p:cNvPicPr>
@@ -3350,8 +3431,8 @@
         </p:blipFill>
         <p:spPr>
           <a:xfrm>
-            <a:off x="1187806" y="4763795"/>
-            <a:ext cx="5186477" cy="3103588"/>
+            <a:off x="928482" y="5150383"/>
+            <a:ext cx="5705124" cy="3413946"/>
           </a:xfrm>
           <a:prstGeom prst="rect">
             <a:avLst/>
@@ -3360,13 +3441,13 @@
       </p:pic>
       <p:sp>
         <p:nvSpPr>
-          <p:cNvPr id="15" name="Text 10"/>
-          <p:cNvSpPr txBox="1"/>
-          <p:nvPr/>
-        </p:nvSpPr>
-        <p:spPr>
-          <a:xfrm>
-            <a:off x="539496" y="7922247"/>
+          <p:cNvPr id="16" name="Text 11"/>
+          <p:cNvSpPr txBox="1"/>
+          <p:nvPr/>
+        </p:nvSpPr>
+        <p:spPr>
+          <a:xfrm>
+            <a:off x="539496" y="8619194"/>
             <a:ext cx="6483096" cy="802767"/>
           </a:xfrm>
           <a:prstGeom prst="rect">
@@ -3395,87 +3476,6 @@
                 <a:cs typeface="Nunito" pitchFamily="34" charset="-120"/>
               </a:rPr>
               <a:t>Orders of EUR 7.1bn beat consensus by 12% and the EUV share rose to 58%, the highest since Q2 2024, while gross margin reached 53.4% against a guide of 51 to 53%. We read the mix shift as structural rather than cyclical, and the guidance for Q4 implies a run-rate above the FY27 consensus. The debate now moves from demand to capacity. Orders of EUR 7.1bn beat consensus by 12% and the EUV share rose to 58%, the highest since Q2 2024, while gross margin reached 53.4% against a guide of 51 to 53%. We.</a:t>
-            </a:r>
-            <a:endParaRPr lang="en-US" sz="870" dirty="0"/>
-          </a:p>
-        </p:txBody>
-      </p:sp>
-      <p:sp>
-        <p:nvSpPr>
-          <p:cNvPr id="16" name="Text 11"/>
-          <p:cNvSpPr txBox="1"/>
-          <p:nvPr/>
-        </p:nvSpPr>
-        <p:spPr>
-          <a:xfrm>
-            <a:off x="539496" y="8841143"/>
-            <a:ext cx="6483096" cy="219456"/>
-          </a:xfrm>
-          <a:prstGeom prst="rect">
-            <a:avLst/>
-          </a:prstGeom>
-          <a:noFill/>
-          <a:ln/>
-        </p:spPr>
-        <p:txBody>
-          <a:bodyPr wrap="square" lIns="0" tIns="0" rIns="0" bIns="0" rtlCol="0" anchor="t"/>
-          <a:lstStyle/>
-          <a:p>
-            <a:pPr indent="0" marL="0">
-              <a:buNone/>
-            </a:pPr>
-            <a:r>
-              <a:rPr lang="en-US" sz="1100" b="1" dirty="0">
-                <a:solidFill>
-                  <a:srgbClr val="202945"/>
-                </a:solidFill>
-                <a:latin typeface="Nunito" pitchFamily="34" charset="0"/>
-                <a:ea typeface="Nunito" pitchFamily="34" charset="-122"/>
-                <a:cs typeface="Nunito" pitchFamily="34" charset="-120"/>
-              </a:rPr>
-              <a:t>Investment implications and positioning</a:t>
-            </a:r>
-            <a:endParaRPr lang="en-US" sz="1100" dirty="0"/>
-          </a:p>
-        </p:txBody>
-      </p:sp>
-      <p:sp>
-        <p:nvSpPr>
-          <p:cNvPr id="17" name="Text 12"/>
-          <p:cNvSpPr txBox="1"/>
-          <p:nvPr/>
-        </p:nvSpPr>
-        <p:spPr>
-          <a:xfrm>
-            <a:off x="539496" y="9088031"/>
-            <a:ext cx="6483096" cy="802767"/>
-          </a:xfrm>
-          <a:prstGeom prst="rect">
-            <a:avLst/>
-          </a:prstGeom>
-          <a:noFill/>
-          <a:ln/>
-        </p:spPr>
-        <p:txBody>
-          <a:bodyPr wrap="square" lIns="0" tIns="0" rIns="0" bIns="0" rtlCol="0" anchor="t"/>
-          <a:lstStyle/>
-          <a:p>
-            <a:pPr algn="just" indent="0" marL="0">
-              <a:lnSpc>
-                <a:spcPct val="118333"/>
-              </a:lnSpc>
-              <a:buNone/>
-            </a:pPr>
-            <a:r>
-              <a:rPr lang="en-US" sz="870" b="1" dirty="0">
-                <a:solidFill>
-                  <a:srgbClr val="202945"/>
-                </a:solidFill>
-                <a:latin typeface="Nunito" pitchFamily="34" charset="0"/>
-                <a:ea typeface="Nunito" pitchFamily="34" charset="-122"/>
-                <a:cs typeface="Nunito" pitchFamily="34" charset="-120"/>
-              </a:rPr>
-              <a:t>Orders of EUR 7.1bn beat consensus by 12% and the EUV share rose to 58%, the highest since Q2 2024, while gross margin reached 53.4% against a guide of 51 to 53%. We read the mix shift as structural rather than cyclical, and the guidance for Q4 implies a run-rate above the FY27 consensus. The debate now moves from demand to capacity. Orders of EUR 7.1bn beat consensus by 12% and the EUV share rose to 58%, the highest since Q2 2024, while gross margin reached 53.4% against a guide of 51 to 53%. We read the mix shift as.</a:t>
             </a:r>
             <a:endParaRPr lang="en-US" sz="870" dirty="0"/>
           </a:p>
@@ -3515,7 +3515,7 @@
       </p:grpSpPr>
       <p:pic>
         <p:nvPicPr>
-          <p:cNvPr id="2" name="Image 0" descr="/home/claude/syz_logo_new.png">    </p:cNvPr>
+          <p:cNvPr id="2" name="Image 0" descr="/home/claude/syz_logo_hq.png">    </p:cNvPr>
           <p:cNvPicPr>
             <a:picLocks noChangeAspect="1"/>
           </p:cNvPicPr>
@@ -3647,7 +3647,7 @@
         </p:nvSpPr>
         <p:spPr>
           <a:xfrm>
-            <a:off x="539496" y="5881624"/>
+            <a:off x="539496" y="5664708"/>
             <a:ext cx="6483096" cy="182880"/>
           </a:xfrm>
           <a:prstGeom prst="rect">
@@ -3664,7 +3664,7 @@
               <a:buNone/>
             </a:pPr>
             <a:r>
-              <a:rPr lang="en-US" sz="680" b="1" dirty="0">
+              <a:rPr lang="en-US" sz="700" b="1" dirty="0">
                 <a:solidFill>
                   <a:srgbClr val="FF6C0E"/>
                 </a:solidFill>
@@ -3678,7 +3678,7 @@
               <a:buNone/>
             </a:pPr>
             <a:r>
-              <a:rPr lang="en-US" sz="680" b="1" dirty="0">
+              <a:rPr lang="en-US" sz="700" b="1" dirty="0">
                 <a:solidFill>
                   <a:srgbClr val="9AA0A8"/>
                 </a:solidFill>
@@ -3688,7 +3688,7 @@
               </a:rPr>
               <a:t> Source: Syz Research, Bloomberg, company filings</a:t>
             </a:r>
-            <a:endParaRPr lang="en-US" sz="680" dirty="0"/>
+            <a:endParaRPr lang="en-US" sz="700" dirty="0"/>
           </a:p>
         </p:txBody>
       </p:sp>
@@ -3700,7 +3700,7 @@
         </p:nvSpPr>
         <p:spPr>
           <a:xfrm>
-            <a:off x="539496" y="6210808"/>
+            <a:off x="539496" y="5993892"/>
             <a:ext cx="6483096" cy="182880"/>
           </a:xfrm>
           <a:prstGeom prst="rect">
@@ -3717,7 +3717,7 @@
               <a:buNone/>
             </a:pPr>
             <a:r>
-              <a:rPr lang="en-US" sz="680" b="1" spc="120" kern="0" dirty="0">
+              <a:rPr lang="en-US" sz="700" b="1" spc="120" kern="0" dirty="0">
                 <a:solidFill>
                   <a:srgbClr val="FF6C0E"/>
                 </a:solidFill>
@@ -3727,7 +3727,7 @@
               </a:rPr>
               <a:t>Disclaimer</a:t>
             </a:r>
-            <a:endParaRPr lang="en-US" sz="680" dirty="0"/>
+            <a:endParaRPr lang="en-US" sz="700" dirty="0"/>
           </a:p>
         </p:txBody>
       </p:sp>
@@ -3739,8 +3739,8 @@
         </p:nvSpPr>
         <p:spPr>
           <a:xfrm>
-            <a:off x="539496" y="6393688"/>
-            <a:ext cx="6483096" cy="538480"/>
+            <a:off x="539496" y="6176772"/>
+            <a:ext cx="6483096" cy="552704"/>
           </a:xfrm>
           <a:prstGeom prst="rect">
             <a:avLst/>
@@ -3759,7 +3759,7 @@
               <a:buNone/>
             </a:pPr>
             <a:r>
-              <a:rPr lang="en-US" sz="680" b="1" dirty="0">
+              <a:rPr lang="en-US" sz="700" b="1" dirty="0">
                 <a:solidFill>
                   <a:srgbClr val="9AA0A8"/>
                 </a:solidFill>
@@ -3769,7 +3769,7 @@
               </a:rPr>
               <a:t>This communication has been issued and made available to recipients for the purpose of advertising investment services and/or financial instruments. It has been sent for information purposes and cannot be considered as an offer or a personalised recommendation to buy or sell a financial instrument or any other investment or currency. This communication does not constitute investment research within the meaning of regulatory rules applicable in the European Economic Area, or research under the rules of the U.S. Self-Regulatory Organizations.</a:t>
             </a:r>
-            <a:endParaRPr lang="en-US" sz="680" dirty="0"/>
+            <a:endParaRPr lang="en-US" sz="700" dirty="0"/>
           </a:p>
         </p:txBody>
       </p:sp>
@@ -3781,8 +3781,8 @@
         </p:nvSpPr>
         <p:spPr>
           <a:xfrm>
-            <a:off x="539496" y="6932168"/>
-            <a:ext cx="6483096" cy="417576"/>
+            <a:off x="539496" y="6729476"/>
+            <a:ext cx="6483096" cy="428244"/>
           </a:xfrm>
           <a:prstGeom prst="rect">
             <a:avLst/>
@@ -3801,7 +3801,7 @@
               <a:buNone/>
             </a:pPr>
             <a:r>
-              <a:rPr lang="en-US" sz="680" b="1" dirty="0">
+              <a:rPr lang="en-US" sz="700" b="1" dirty="0">
                 <a:solidFill>
                   <a:srgbClr val="9AA0A8"/>
                 </a:solidFill>
@@ -3811,7 +3811,7 @@
               </a:rPr>
               <a:t>This information is made solely for professional and institutional clients as defined by the Swiss Financial Services Act, as well as qualified investors according to the Swiss Collective Investment Schemes Act. It is not intended for retail clients or non-qualified investors and consequently cannot be transmitted to any third party.</a:t>
             </a:r>
-            <a:endParaRPr lang="en-US" sz="680" dirty="0"/>
+            <a:endParaRPr lang="en-US" sz="700" dirty="0"/>
           </a:p>
         </p:txBody>
       </p:sp>
@@ -3823,8 +3823,8 @@
         </p:nvSpPr>
         <p:spPr>
           <a:xfrm>
-            <a:off x="539496" y="7349744"/>
-            <a:ext cx="6483096" cy="417576"/>
+            <a:off x="539496" y="7157720"/>
+            <a:ext cx="6483096" cy="428244"/>
           </a:xfrm>
           <a:prstGeom prst="rect">
             <a:avLst/>
@@ -3843,7 +3843,7 @@
               <a:buNone/>
             </a:pPr>
             <a:r>
-              <a:rPr lang="en-US" sz="680" b="1" dirty="0">
+              <a:rPr lang="en-US" sz="700" b="1" dirty="0">
                 <a:solidFill>
                   <a:srgbClr val="9AA0A8"/>
                 </a:solidFill>
@@ -3853,7 +3853,7 @@
               </a:rPr>
               <a:t>This communication is not directed to any person in any jurisdiction where, by reason of that person’s nationality, residence or otherwise, its dissemination or use is prohibited. It cannot be quoted, reproduced, disclosed, distributed or otherwise referred to, in whole or in part, to any third party without the Bank’s prior written consent.</a:t>
             </a:r>
-            <a:endParaRPr lang="en-US" sz="680" dirty="0"/>
+            <a:endParaRPr lang="en-US" sz="700" dirty="0"/>
           </a:p>
         </p:txBody>
       </p:sp>
@@ -3865,8 +3865,8 @@
         </p:nvSpPr>
         <p:spPr>
           <a:xfrm>
-            <a:off x="539496" y="7767320"/>
-            <a:ext cx="6483096" cy="780288"/>
+            <a:off x="539496" y="7585964"/>
+            <a:ext cx="6483096" cy="801624"/>
           </a:xfrm>
           <a:prstGeom prst="rect">
             <a:avLst/>
@@ -3885,7 +3885,7 @@
               <a:buNone/>
             </a:pPr>
             <a:r>
-              <a:rPr lang="en-US" sz="680" b="1" dirty="0">
+              <a:rPr lang="en-US" sz="700" b="1" dirty="0">
                 <a:solidFill>
                   <a:srgbClr val="9AA0A8"/>
                 </a:solidFill>
@@ -3895,7 +3895,7 @@
               </a:rPr>
               <a:t>This communication may contain information on past performances of a financial product, all kinds of economic and financial valuations and analyses, as well as opinions of the Bank or of third parties. Any market valuations, terms and calculation methods, yields and opinions expressed are subject to change without notice. The information and opinions contained herein have been compiled and provided in good faith, based on information obtained from sources believed to be trustworthy. However, such information has not been independently verified. No guarantee, representation, or warranty of any kind, whether express or implied, is provided by the Bank or by relevant data vendors and other sources with respect to the accuracy, reliability, currentness or exhaustiveness of the information communicated, the methodology employed or the prices contained herein.</a:t>
             </a:r>
-            <a:endParaRPr lang="en-US" sz="680" dirty="0"/>
+            <a:endParaRPr lang="en-US" sz="700" dirty="0"/>
           </a:p>
         </p:txBody>
       </p:sp>
@@ -3907,8 +3907,8 @@
         </p:nvSpPr>
         <p:spPr>
           <a:xfrm>
-            <a:off x="539496" y="8547608"/>
-            <a:ext cx="6483096" cy="296672"/>
+            <a:off x="539496" y="8387588"/>
+            <a:ext cx="6483096" cy="303784"/>
           </a:xfrm>
           <a:prstGeom prst="rect">
             <a:avLst/>
@@ -3927,7 +3927,7 @@
               <a:buNone/>
             </a:pPr>
             <a:r>
-              <a:rPr lang="en-US" sz="680" b="1" dirty="0">
+              <a:rPr lang="en-US" sz="700" b="1" dirty="0">
                 <a:solidFill>
                   <a:srgbClr val="9AA0A8"/>
                 </a:solidFill>
@@ -3937,7 +3937,7 @@
               </a:rPr>
               <a:t>Past performance is not a reliable indicator of current or future results. Any reference to the past performance of an investment does not guarantee its future performance. Fluctuations in exchange rates may adversely affect the value, price or income of any investment.</a:t>
             </a:r>
-            <a:endParaRPr lang="en-US" sz="680" dirty="0"/>
+            <a:endParaRPr lang="en-US" sz="700" dirty="0"/>
           </a:p>
         </p:txBody>
       </p:sp>
@@ -3949,8 +3949,8 @@
         </p:nvSpPr>
         <p:spPr>
           <a:xfrm>
-            <a:off x="539496" y="8844280"/>
-            <a:ext cx="6483096" cy="659384"/>
+            <a:off x="539496" y="8691372"/>
+            <a:ext cx="6483096" cy="801624"/>
           </a:xfrm>
           <a:prstGeom prst="rect">
             <a:avLst/>
@@ -3969,7 +3969,7 @@
               <a:buNone/>
             </a:pPr>
             <a:r>
-              <a:rPr lang="en-US" sz="680" b="1" dirty="0">
+              <a:rPr lang="en-US" sz="700" b="1" dirty="0">
                 <a:solidFill>
                   <a:srgbClr val="9AA0A8"/>
                 </a:solidFill>
@@ -3979,7 +3979,7 @@
               </a:rPr>
               <a:t>Nothing in the present communication constitutes investment, legal, accounting or tax advice. This information is purely objective since it does not take into consideration the personal situation (including financial knowledge and experience), the investment objectives and risk profile of any recipient. Moreover, certain financial instruments mentioned (in particular, but not exclusively, derivatives, options and futures) involve a high risk of loss and may not be suitable. Accordingly, recipients should consult their own advisors on such matters, including but not limited to the possible tax consequences of investing in any financial product mentioned herein, and make their own assessment of the suitability of such investment product.</a:t>
             </a:r>
-            <a:endParaRPr lang="en-US" sz="680" dirty="0"/>
+            <a:endParaRPr lang="en-US" sz="700" dirty="0"/>
           </a:p>
         </p:txBody>
       </p:sp>
@@ -3991,8 +3991,8 @@
         </p:nvSpPr>
         <p:spPr>
           <a:xfrm>
-            <a:off x="539496" y="9503664"/>
-            <a:ext cx="6483096" cy="417576"/>
+            <a:off x="539496" y="9492996"/>
+            <a:ext cx="6483096" cy="428244"/>
           </a:xfrm>
           <a:prstGeom prst="rect">
             <a:avLst/>
@@ -4011,7 +4011,7 @@
               <a:buNone/>
             </a:pPr>
             <a:r>
-              <a:rPr lang="en-US" sz="680" b="1" dirty="0">
+              <a:rPr lang="en-US" sz="700" b="1" dirty="0">
                 <a:solidFill>
                   <a:srgbClr val="9AA0A8"/>
                 </a:solidFill>
@@ -4021,7 +4021,7 @@
               </a:rPr>
               <a:t>Should a recipient make an investment on the basis of the present communication, the recipient alone shall bear the consequences thereof. In no event shall the Bank, its directors, employees, affiliates or agents be held responsible for damages of any kind arising out of the use of all or part of the information provided herein.</a:t>
             </a:r>
-            <a:endParaRPr lang="en-US" sz="680" dirty="0"/>
+            <a:endParaRPr lang="en-US" sz="700" dirty="0"/>
           </a:p>
         </p:txBody>
       </p:sp>

</xml_diff>

<commit_message>
Two rounded boxes on page 1 (key numbers, base case with strengthen/change columns), positioning verbs only for Focus List names, SK hynix Q3 2026 reference instance
Co-Authored-By: Claude Fable 5.1 <noreply@anthropic.com>
Claude-Session: https://claude.ai/code/session_01LT5UcsMFmVUzPC7QX6JrXv
</commit_message>
<xml_diff>
--- a/examples/layout_calibration.pptx
+++ b/examples/layout_calibration.pptx
@@ -1821,8 +1821,10 @@
             <a:off x="539496" y="4102786"/>
             <a:ext cx="6483096" cy="640080"/>
           </a:xfrm>
-          <a:prstGeom prst="rect">
-            <a:avLst/>
+          <a:prstGeom prst="roundRect">
+            <a:avLst>
+              <a:gd name="adj" fmla="val 14286"/>
+            </a:avLst>
           </a:prstGeom>
           <a:solidFill>
             <a:srgbClr val="FFFFFF"/>
@@ -2622,8 +2624,8 @@
         </p:nvSpPr>
         <p:spPr>
           <a:xfrm>
-            <a:off x="539496" y="8007147"/>
-            <a:ext cx="6483096" cy="219456"/>
+            <a:off x="658368" y="8052867"/>
+            <a:ext cx="6245352" cy="219456"/>
           </a:xfrm>
           <a:prstGeom prst="rect">
             <a:avLst/>
@@ -2661,8 +2663,8 @@
         </p:nvSpPr>
         <p:spPr>
           <a:xfrm>
-            <a:off x="539496" y="8254035"/>
-            <a:ext cx="6483096" cy="645871"/>
+            <a:off x="658368" y="8299755"/>
+            <a:ext cx="6245352" cy="645871"/>
           </a:xfrm>
           <a:prstGeom prst="rect">
             <a:avLst/>
@@ -2703,7 +2705,7 @@
         </p:nvSpPr>
         <p:spPr>
           <a:xfrm>
-            <a:off x="3781044" y="9016035"/>
+            <a:off x="3781044" y="9043467"/>
             <a:ext cx="0" cy="828751"/>
           </a:xfrm>
           <a:prstGeom prst="line">
@@ -2726,8 +2728,8 @@
         </p:nvSpPr>
         <p:spPr>
           <a:xfrm>
-            <a:off x="539496" y="9016035"/>
-            <a:ext cx="3058668" cy="155448"/>
+            <a:off x="658368" y="9043467"/>
+            <a:ext cx="2939796" cy="155448"/>
           </a:xfrm>
           <a:prstGeom prst="rect">
             <a:avLst/>
@@ -2765,8 +2767,8 @@
         </p:nvSpPr>
         <p:spPr>
           <a:xfrm>
-            <a:off x="539496" y="9208059"/>
-            <a:ext cx="3058668" cy="627583"/>
+            <a:off x="658368" y="9235491"/>
+            <a:ext cx="2939796" cy="627583"/>
           </a:xfrm>
           <a:prstGeom prst="rect">
             <a:avLst/>
@@ -2807,8 +2809,8 @@
         </p:nvSpPr>
         <p:spPr>
           <a:xfrm>
-            <a:off x="3963924" y="9016035"/>
-            <a:ext cx="3058668" cy="155448"/>
+            <a:off x="3963924" y="9043467"/>
+            <a:ext cx="2939796" cy="155448"/>
           </a:xfrm>
           <a:prstGeom prst="rect">
             <a:avLst/>
@@ -2846,8 +2848,8 @@
         </p:nvSpPr>
         <p:spPr>
           <a:xfrm>
-            <a:off x="3963924" y="9208059"/>
-            <a:ext cx="3058668" cy="627583"/>
+            <a:off x="3963924" y="9235491"/>
+            <a:ext cx="2939796" cy="627583"/>
           </a:xfrm>
           <a:prstGeom prst="rect">
             <a:avLst/>
@@ -2879,6 +2881,30 @@
             <a:endParaRPr lang="en-US" sz="870" dirty="0"/>
           </a:p>
         </p:txBody>
+      </p:sp>
+      <p:sp>
+        <p:nvSpPr>
+          <p:cNvPr id="51" name="Shape 46"/>
+          <p:cNvSpPr/>
+          <p:nvPr/>
+        </p:nvSpPr>
+        <p:spPr>
+          <a:xfrm>
+            <a:off x="539496" y="7988859"/>
+            <a:ext cx="6483096" cy="1947367"/>
+          </a:xfrm>
+          <a:prstGeom prst="roundRect">
+            <a:avLst>
+              <a:gd name="adj" fmla="val 4696"/>
+            </a:avLst>
+          </a:prstGeom>
+          <a:ln w="16510">
+            <a:solidFill>
+              <a:srgbClr val="202945"/>
+            </a:solidFill>
+            <a:prstDash val="solid"/>
+          </a:ln>
+        </p:spPr>
       </p:sp>
     </p:spTree>
   </p:cSld>

</xml_diff>